<commit_message>
Rewrite Inference Extension request processing intro for redrawn Figure 3
</commit_message>
<xml_diff>
--- a/content/docs/theory-analysis/istio-gateway-api-inference-extension/images/images.pptx
+++ b/content/docs/theory-analysis/istio-gateway-api-inference-extension/images/images.pptx
@@ -5,17 +5,18 @@
     <p:sldMasterId id="2147483648" r:id="rId1"/>
   </p:sldMasterIdLst>
   <p:notesMasterIdLst>
-    <p:notesMasterId r:id="rId10"/>
+    <p:notesMasterId r:id="rId11"/>
   </p:notesMasterIdLst>
   <p:sldIdLst>
     <p:sldId id="443" r:id="rId2"/>
     <p:sldId id="453" r:id="rId3"/>
-    <p:sldId id="437" r:id="rId4"/>
-    <p:sldId id="442" r:id="rId5"/>
-    <p:sldId id="441" r:id="rId6"/>
-    <p:sldId id="440" r:id="rId7"/>
-    <p:sldId id="439" r:id="rId8"/>
-    <p:sldId id="438" r:id="rId9"/>
+    <p:sldId id="454" r:id="rId4"/>
+    <p:sldId id="437" r:id="rId5"/>
+    <p:sldId id="442" r:id="rId6"/>
+    <p:sldId id="441" r:id="rId7"/>
+    <p:sldId id="440" r:id="rId8"/>
+    <p:sldId id="439" r:id="rId9"/>
+    <p:sldId id="438" r:id="rId10"/>
   </p:sldIdLst>
   <p:sldSz cx="9144000" cy="5143500" type="screen16x9"/>
   <p:notesSz cx="6858000" cy="9144000"/>
@@ -660,7 +661,7 @@
           <a:p>
             <a:fld id="{BA5DFA43-8D57-47FB-BC46-057616015C3B}" type="slidenum">
               <a:rPr lang="ko-KR" altLang="en-US" smtClean="0"/>
-              <a:t>4</a:t>
+              <a:t>5</a:t>
             </a:fld>
             <a:endParaRPr lang="ko-KR" altLang="en-US"/>
           </a:p>
@@ -768,7 +769,7 @@
           <a:p>
             <a:fld id="{BA5DFA43-8D57-47FB-BC46-057616015C3B}" type="slidenum">
               <a:rPr lang="ko-KR" altLang="en-US" smtClean="0"/>
-              <a:t>5</a:t>
+              <a:t>6</a:t>
             </a:fld>
             <a:endParaRPr lang="ko-KR" altLang="en-US"/>
           </a:p>
@@ -876,7 +877,7 @@
           <a:p>
             <a:fld id="{BA5DFA43-8D57-47FB-BC46-057616015C3B}" type="slidenum">
               <a:rPr lang="ko-KR" altLang="en-US" smtClean="0"/>
-              <a:t>6</a:t>
+              <a:t>7</a:t>
             </a:fld>
             <a:endParaRPr lang="ko-KR" altLang="en-US"/>
           </a:p>
@@ -984,7 +985,7 @@
           <a:p>
             <a:fld id="{BA5DFA43-8D57-47FB-BC46-057616015C3B}" type="slidenum">
               <a:rPr lang="ko-KR" altLang="en-US" smtClean="0"/>
-              <a:t>7</a:t>
+              <a:t>8</a:t>
             </a:fld>
             <a:endParaRPr lang="ko-KR" altLang="en-US"/>
           </a:p>
@@ -8718,6 +8719,21 @@
           <a:p>
             <a:pPr algn="ctr"/>
             <a:r>
+              <a:rPr lang="en-US" altLang="ko-KR" sz="900"/>
+              <a:t>(</a:t>
+            </a:r>
+            <a:r>
+              <a:rPr lang="en-US" altLang="ko-KR" sz="900" u="sng"/>
+              <a:t>*.ssup2.com</a:t>
+            </a:r>
+            <a:r>
+              <a:rPr lang="en-US" altLang="ko-KR" sz="900"/>
+              <a:t>)</a:t>
+            </a:r>
+          </a:p>
+          <a:p>
+            <a:pPr algn="ctr"/>
+            <a:r>
               <a:rPr lang="en-US" altLang="ko-KR" sz="900" b="1"/>
               <a:t>Gateway</a:t>
             </a:r>
@@ -9029,7 +9045,21 @@
               <a:rPr lang="en-US" altLang="ko-KR" sz="900" dirty="0" err="1"/>
               <a:t>vllm-lama3-8b</a:t>
             </a:r>
-            <a:endParaRPr lang="en-US" altLang="ko-KR" sz="900" dirty="0"/>
+          </a:p>
+          <a:p>
+            <a:pPr algn="ctr"/>
+            <a:r>
+              <a:rPr lang="en-US" altLang="ko-KR" sz="900" dirty="0"/>
+              <a:t>(</a:t>
+            </a:r>
+            <a:r>
+              <a:rPr lang="en-US" altLang="ko-KR" sz="900" u="sng" dirty="0"/>
+              <a:t>llm.ssup2.com</a:t>
+            </a:r>
+            <a:r>
+              <a:rPr lang="en-US" altLang="ko-KR" sz="900" dirty="0"/>
+              <a:t>)</a:t>
+            </a:r>
           </a:p>
           <a:p>
             <a:pPr algn="ctr"/>
@@ -10534,6 +10564,3072 @@
 </file>
 
 <file path=ppt/slides/slide3.xml><?xml version="1.0" encoding="utf-8"?>
+<p:sld xmlns:a="http://schemas.openxmlformats.org/drawingml/2006/main" xmlns:r="http://schemas.openxmlformats.org/officeDocument/2006/relationships" xmlns:p="http://schemas.openxmlformats.org/presentationml/2006/main">
+  <p:cSld>
+    <p:spTree>
+      <p:nvGrpSpPr>
+        <p:cNvPr id="1" name="">
+          <a:extLst>
+            <a:ext uri="{FF2B5EF4-FFF2-40B4-BE49-F238E27FC236}">
+              <a16:creationId xmlns:a16="http://schemas.microsoft.com/office/drawing/2014/main" id="{2878F09A-9FB7-6F38-FE89-1E17541AF814}"/>
+            </a:ext>
+          </a:extLst>
+        </p:cNvPr>
+        <p:cNvGrpSpPr/>
+        <p:nvPr/>
+      </p:nvGrpSpPr>
+      <p:grpSpPr>
+        <a:xfrm>
+          <a:off x="0" y="0"/>
+          <a:ext cx="0" cy="0"/>
+          <a:chOff x="0" y="0"/>
+          <a:chExt cx="0" cy="0"/>
+        </a:xfrm>
+      </p:grpSpPr>
+      <p:sp>
+        <p:nvSpPr>
+          <p:cNvPr id="5" name="사각형: 둥근 모서리 12">
+            <a:extLst>
+              <a:ext uri="{FF2B5EF4-FFF2-40B4-BE49-F238E27FC236}">
+                <a16:creationId xmlns:a16="http://schemas.microsoft.com/office/drawing/2014/main" id="{3FE82974-42E4-96EC-A659-B48D863D0552}"/>
+              </a:ext>
+            </a:extLst>
+          </p:cNvPr>
+          <p:cNvSpPr/>
+          <p:nvPr/>
+        </p:nvSpPr>
+        <p:spPr>
+          <a:xfrm>
+            <a:off x="887811" y="559835"/>
+            <a:ext cx="6618592" cy="3792032"/>
+          </a:xfrm>
+          <a:prstGeom prst="roundRect">
+            <a:avLst>
+              <a:gd name="adj" fmla="val 2807"/>
+            </a:avLst>
+          </a:prstGeom>
+          <a:noFill/>
+          <a:ln w="12700">
+            <a:headEnd type="none" w="med" len="med"/>
+            <a:tailEnd type="triangle" w="med" len="med"/>
+          </a:ln>
+        </p:spPr>
+        <p:style>
+          <a:lnRef idx="2">
+            <a:schemeClr val="dk1"/>
+          </a:lnRef>
+          <a:fillRef idx="1">
+            <a:schemeClr val="lt1"/>
+          </a:fillRef>
+          <a:effectRef idx="0">
+            <a:schemeClr val="dk1"/>
+          </a:effectRef>
+          <a:fontRef idx="minor">
+            <a:schemeClr val="dk1"/>
+          </a:fontRef>
+        </p:style>
+        <p:txBody>
+          <a:bodyPr rtlCol="0" anchor="b"/>
+          <a:lstStyle/>
+          <a:p>
+            <a:pPr algn="ctr"/>
+            <a:r>
+              <a:rPr lang="en-US" altLang="ko-KR" sz="1000"/>
+              <a:t>ingress-gateway </a:t>
+            </a:r>
+            <a:r>
+              <a:rPr lang="en-US" altLang="ko-KR" sz="1000" b="1"/>
+              <a:t>Pod</a:t>
+            </a:r>
+            <a:endParaRPr lang="ko-KR" altLang="en-US" sz="1000" b="1"/>
+          </a:p>
+        </p:txBody>
+      </p:sp>
+      <p:sp>
+        <p:nvSpPr>
+          <p:cNvPr id="6" name="사각형: 둥근 모서리 12">
+            <a:extLst>
+              <a:ext uri="{FF2B5EF4-FFF2-40B4-BE49-F238E27FC236}">
+                <a16:creationId xmlns:a16="http://schemas.microsoft.com/office/drawing/2014/main" id="{236721A9-1778-38A1-FC06-D79F5D1EA81E}"/>
+              </a:ext>
+            </a:extLst>
+          </p:cNvPr>
+          <p:cNvSpPr/>
+          <p:nvPr/>
+        </p:nvSpPr>
+        <p:spPr>
+          <a:xfrm>
+            <a:off x="959819" y="627534"/>
+            <a:ext cx="6478850" cy="3432386"/>
+          </a:xfrm>
+          <a:prstGeom prst="roundRect">
+            <a:avLst>
+              <a:gd name="adj" fmla="val 2990"/>
+            </a:avLst>
+          </a:prstGeom>
+          <a:noFill/>
+          <a:ln w="12700">
+            <a:headEnd type="none" w="med" len="med"/>
+            <a:tailEnd type="triangle" w="med" len="med"/>
+          </a:ln>
+        </p:spPr>
+        <p:style>
+          <a:lnRef idx="2">
+            <a:schemeClr val="dk1"/>
+          </a:lnRef>
+          <a:fillRef idx="1">
+            <a:schemeClr val="lt1"/>
+          </a:fillRef>
+          <a:effectRef idx="0">
+            <a:schemeClr val="dk1"/>
+          </a:effectRef>
+          <a:fontRef idx="minor">
+            <a:schemeClr val="dk1"/>
+          </a:fontRef>
+        </p:style>
+        <p:txBody>
+          <a:bodyPr rtlCol="0" anchor="b"/>
+          <a:lstStyle/>
+          <a:p>
+            <a:pPr algn="ctr"/>
+            <a:r>
+              <a:rPr lang="en-US" altLang="ko-KR" sz="1000"/>
+              <a:t>Ingress envoy</a:t>
+            </a:r>
+            <a:endParaRPr lang="ko-KR" altLang="en-US" sz="1000" b="1"/>
+          </a:p>
+        </p:txBody>
+      </p:sp>
+      <p:sp>
+        <p:nvSpPr>
+          <p:cNvPr id="15" name="사각형: 둥근 모서리 12">
+            <a:extLst>
+              <a:ext uri="{FF2B5EF4-FFF2-40B4-BE49-F238E27FC236}">
+                <a16:creationId xmlns:a16="http://schemas.microsoft.com/office/drawing/2014/main" id="{B2744D4C-0871-B9BF-6099-1896E695712A}"/>
+              </a:ext>
+            </a:extLst>
+          </p:cNvPr>
+          <p:cNvSpPr/>
+          <p:nvPr/>
+        </p:nvSpPr>
+        <p:spPr>
+          <a:xfrm>
+            <a:off x="1031827" y="703852"/>
+            <a:ext cx="6330642" cy="3096343"/>
+          </a:xfrm>
+          <a:prstGeom prst="roundRect">
+            <a:avLst>
+              <a:gd name="adj" fmla="val 3282"/>
+            </a:avLst>
+          </a:prstGeom>
+          <a:solidFill>
+            <a:schemeClr val="bg1">
+              <a:lumMod val="95000"/>
+            </a:schemeClr>
+          </a:solidFill>
+          <a:ln w="12700">
+            <a:headEnd type="none" w="med" len="med"/>
+            <a:tailEnd type="triangle" w="med" len="med"/>
+          </a:ln>
+        </p:spPr>
+        <p:style>
+          <a:lnRef idx="2">
+            <a:schemeClr val="dk1"/>
+          </a:lnRef>
+          <a:fillRef idx="1">
+            <a:schemeClr val="lt1"/>
+          </a:fillRef>
+          <a:effectRef idx="0">
+            <a:schemeClr val="dk1"/>
+          </a:effectRef>
+          <a:fontRef idx="minor">
+            <a:schemeClr val="dk1"/>
+          </a:fontRef>
+        </p:style>
+        <p:txBody>
+          <a:bodyPr rtlCol="0" anchor="t"/>
+          <a:lstStyle/>
+          <a:p>
+            <a:pPr algn="r"/>
+            <a:r>
+              <a:rPr lang="en-US" altLang="ko-KR" sz="1000"/>
+              <a:t>*.ssup2.com </a:t>
+            </a:r>
+            <a:r>
+              <a:rPr lang="en-US" altLang="ko-KR" sz="1000" b="1"/>
+              <a:t>Network Filters </a:t>
+            </a:r>
+            <a:endParaRPr lang="ko-KR" altLang="en-US" sz="1000" b="1"/>
+          </a:p>
+        </p:txBody>
+      </p:sp>
+      <p:sp>
+        <p:nvSpPr>
+          <p:cNvPr id="23" name="사각형: 둥근 모서리 12">
+            <a:extLst>
+              <a:ext uri="{FF2B5EF4-FFF2-40B4-BE49-F238E27FC236}">
+                <a16:creationId xmlns:a16="http://schemas.microsoft.com/office/drawing/2014/main" id="{052E2AAD-7357-136C-C833-32C60A648BB3}"/>
+              </a:ext>
+            </a:extLst>
+          </p:cNvPr>
+          <p:cNvSpPr/>
+          <p:nvPr/>
+        </p:nvSpPr>
+        <p:spPr>
+          <a:xfrm>
+            <a:off x="1103835" y="988966"/>
+            <a:ext cx="4579672" cy="2739221"/>
+          </a:xfrm>
+          <a:prstGeom prst="roundRect">
+            <a:avLst>
+              <a:gd name="adj" fmla="val 2895"/>
+            </a:avLst>
+          </a:prstGeom>
+          <a:solidFill>
+            <a:schemeClr val="bg1">
+              <a:lumMod val="95000"/>
+            </a:schemeClr>
+          </a:solidFill>
+          <a:ln w="12700">
+            <a:headEnd type="none" w="med" len="med"/>
+            <a:tailEnd type="triangle" w="med" len="med"/>
+          </a:ln>
+        </p:spPr>
+        <p:style>
+          <a:lnRef idx="2">
+            <a:schemeClr val="dk1"/>
+          </a:lnRef>
+          <a:fillRef idx="1">
+            <a:schemeClr val="lt1"/>
+          </a:fillRef>
+          <a:effectRef idx="0">
+            <a:schemeClr val="dk1"/>
+          </a:effectRef>
+          <a:fontRef idx="minor">
+            <a:schemeClr val="dk1"/>
+          </a:fontRef>
+        </p:style>
+        <p:txBody>
+          <a:bodyPr rtlCol="0" anchor="b"/>
+          <a:lstStyle/>
+          <a:p>
+            <a:pPr algn="ctr"/>
+            <a:r>
+              <a:rPr lang="en-US" altLang="ko-KR" sz="1000" b="1"/>
+              <a:t>HCM (HTTP Connection Manager)</a:t>
+            </a:r>
+            <a:endParaRPr lang="ko-KR" altLang="en-US" sz="1000" b="1"/>
+          </a:p>
+        </p:txBody>
+      </p:sp>
+      <p:sp>
+        <p:nvSpPr>
+          <p:cNvPr id="24" name="사각형: 둥근 모서리 12">
+            <a:extLst>
+              <a:ext uri="{FF2B5EF4-FFF2-40B4-BE49-F238E27FC236}">
+                <a16:creationId xmlns:a16="http://schemas.microsoft.com/office/drawing/2014/main" id="{73C64508-2389-07F5-1324-F4B35D94DCF1}"/>
+              </a:ext>
+            </a:extLst>
+          </p:cNvPr>
+          <p:cNvSpPr/>
+          <p:nvPr/>
+        </p:nvSpPr>
+        <p:spPr>
+          <a:xfrm>
+            <a:off x="113347" y="1156318"/>
+            <a:ext cx="702456" cy="442788"/>
+          </a:xfrm>
+          <a:prstGeom prst="roundRect">
+            <a:avLst>
+              <a:gd name="adj" fmla="val 14105"/>
+            </a:avLst>
+          </a:prstGeom>
+          <a:noFill/>
+          <a:ln w="12700">
+            <a:headEnd type="none" w="med" len="med"/>
+            <a:tailEnd type="triangle" w="med" len="med"/>
+          </a:ln>
+        </p:spPr>
+        <p:style>
+          <a:lnRef idx="2">
+            <a:schemeClr val="dk1"/>
+          </a:lnRef>
+          <a:fillRef idx="1">
+            <a:schemeClr val="lt1"/>
+          </a:fillRef>
+          <a:effectRef idx="0">
+            <a:schemeClr val="dk1"/>
+          </a:effectRef>
+          <a:fontRef idx="minor">
+            <a:schemeClr val="dk1"/>
+          </a:fontRef>
+        </p:style>
+        <p:txBody>
+          <a:bodyPr rtlCol="0" anchor="ctr"/>
+          <a:lstStyle/>
+          <a:p>
+            <a:pPr algn="ctr"/>
+            <a:r>
+              <a:rPr lang="en-US" altLang="ko-KR" sz="900" dirty="0" err="1"/>
+              <a:t>curl</a:t>
+            </a:r>
+            <a:r>
+              <a:rPr lang="en-US" altLang="ko-KR" sz="900" b="1" dirty="0" err="1"/>
+              <a:t> </a:t>
+            </a:r>
+          </a:p>
+          <a:p>
+            <a:pPr algn="ctr"/>
+            <a:r>
+              <a:rPr lang="en-US" altLang="ko-KR" sz="900" b="1" dirty="0" err="1"/>
+              <a:t>Client</a:t>
+            </a:r>
+            <a:endParaRPr lang="en-US" altLang="ko-KR" sz="900" dirty="0"/>
+          </a:p>
+        </p:txBody>
+      </p:sp>
+      <p:cxnSp>
+        <p:nvCxnSpPr>
+          <p:cNvPr id="25" name="직선 화살표 연결선 96">
+            <a:extLst>
+              <a:ext uri="{FF2B5EF4-FFF2-40B4-BE49-F238E27FC236}">
+                <a16:creationId xmlns:a16="http://schemas.microsoft.com/office/drawing/2014/main" id="{5A8DD95B-FB39-F9AA-5EB9-B17B0E642724}"/>
+              </a:ext>
+            </a:extLst>
+          </p:cNvPr>
+          <p:cNvCxnSpPr>
+            <a:cxnSpLocks/>
+            <a:stCxn id="24" idx="3"/>
+            <a:endCxn id="34" idx="1"/>
+          </p:cNvCxnSpPr>
+          <p:nvPr/>
+        </p:nvCxnSpPr>
+        <p:spPr>
+          <a:xfrm flipV="1">
+            <a:off x="815803" y="1289974"/>
+            <a:ext cx="504423" cy="87738"/>
+          </a:xfrm>
+          <a:prstGeom prst="straightConnector1">
+            <a:avLst/>
+          </a:prstGeom>
+          <a:ln w="12700">
+            <a:solidFill>
+              <a:srgbClr val="C00000"/>
+            </a:solidFill>
+            <a:prstDash val="solid"/>
+            <a:headEnd type="none" w="med" len="med"/>
+            <a:tailEnd type="triangle" w="med" len="med"/>
+          </a:ln>
+        </p:spPr>
+        <p:style>
+          <a:lnRef idx="1">
+            <a:schemeClr val="accent1"/>
+          </a:lnRef>
+          <a:fillRef idx="0">
+            <a:schemeClr val="accent1"/>
+          </a:fillRef>
+          <a:effectRef idx="0">
+            <a:schemeClr val="accent1"/>
+          </a:effectRef>
+          <a:fontRef idx="minor">
+            <a:schemeClr val="tx1"/>
+          </a:fontRef>
+        </p:style>
+      </p:cxnSp>
+      <p:sp>
+        <p:nvSpPr>
+          <p:cNvPr id="33" name="사각형: 둥근 모서리 70">
+            <a:extLst>
+              <a:ext uri="{FF2B5EF4-FFF2-40B4-BE49-F238E27FC236}">
+                <a16:creationId xmlns:a16="http://schemas.microsoft.com/office/drawing/2014/main" id="{388D61F8-6FD7-1331-2D34-6F12F7C3BA1C}"/>
+              </a:ext>
+            </a:extLst>
+          </p:cNvPr>
+          <p:cNvSpPr/>
+          <p:nvPr/>
+        </p:nvSpPr>
+        <p:spPr>
+          <a:xfrm>
+            <a:off x="1175845" y="1567245"/>
+            <a:ext cx="4437368" cy="1811072"/>
+          </a:xfrm>
+          <a:prstGeom prst="roundRect">
+            <a:avLst>
+              <a:gd name="adj" fmla="val 5061"/>
+            </a:avLst>
+          </a:prstGeom>
+          <a:noFill/>
+          <a:ln w="12700">
+            <a:prstDash val="dash"/>
+            <a:headEnd type="none" w="med" len="med"/>
+            <a:tailEnd type="triangle" w="med" len="med"/>
+          </a:ln>
+        </p:spPr>
+        <p:style>
+          <a:lnRef idx="2">
+            <a:schemeClr val="dk1"/>
+          </a:lnRef>
+          <a:fillRef idx="1">
+            <a:schemeClr val="lt1"/>
+          </a:fillRef>
+          <a:effectRef idx="0">
+            <a:schemeClr val="dk1"/>
+          </a:effectRef>
+          <a:fontRef idx="minor">
+            <a:schemeClr val="dk1"/>
+          </a:fontRef>
+        </p:style>
+        <p:txBody>
+          <a:bodyPr rtlCol="0" anchor="t"/>
+          <a:lstStyle/>
+          <a:p>
+            <a:pPr algn="r"/>
+            <a:r>
+              <a:rPr lang="en-US" altLang="ko-KR" sz="1000"/>
+              <a:t>Per Downstream Request/Stream Instances</a:t>
+            </a:r>
+            <a:endParaRPr lang="ko-KR" altLang="en-US" sz="1000"/>
+          </a:p>
+        </p:txBody>
+      </p:sp>
+      <p:sp>
+        <p:nvSpPr>
+          <p:cNvPr id="34" name="사각형: 둥근 모서리 12">
+            <a:extLst>
+              <a:ext uri="{FF2B5EF4-FFF2-40B4-BE49-F238E27FC236}">
+                <a16:creationId xmlns:a16="http://schemas.microsoft.com/office/drawing/2014/main" id="{8C8C9AF0-B55B-981B-2D6C-F81F8E7C5006}"/>
+              </a:ext>
+            </a:extLst>
+          </p:cNvPr>
+          <p:cNvSpPr/>
+          <p:nvPr/>
+        </p:nvSpPr>
+        <p:spPr>
+          <a:xfrm>
+            <a:off x="1320226" y="1109296"/>
+            <a:ext cx="1139438" cy="361356"/>
+          </a:xfrm>
+          <a:prstGeom prst="roundRect">
+            <a:avLst>
+              <a:gd name="adj" fmla="val 14105"/>
+            </a:avLst>
+          </a:prstGeom>
+          <a:solidFill>
+            <a:schemeClr val="bg1">
+              <a:lumMod val="95000"/>
+            </a:schemeClr>
+          </a:solidFill>
+          <a:ln w="12700">
+            <a:headEnd type="none" w="med" len="med"/>
+            <a:tailEnd type="triangle" w="med" len="med"/>
+          </a:ln>
+        </p:spPr>
+        <p:style>
+          <a:lnRef idx="2">
+            <a:schemeClr val="dk1"/>
+          </a:lnRef>
+          <a:fillRef idx="1">
+            <a:schemeClr val="lt1"/>
+          </a:fillRef>
+          <a:effectRef idx="0">
+            <a:schemeClr val="dk1"/>
+          </a:effectRef>
+          <a:fontRef idx="minor">
+            <a:schemeClr val="dk1"/>
+          </a:fontRef>
+        </p:style>
+        <p:txBody>
+          <a:bodyPr rtlCol="0" anchor="ctr"/>
+          <a:lstStyle/>
+          <a:p>
+            <a:pPr algn="ctr"/>
+            <a:r>
+              <a:rPr lang="en-US" altLang="ko-KR" sz="900" b="1"/>
+              <a:t>HTTP Codec</a:t>
+            </a:r>
+            <a:endParaRPr lang="ko-KR" altLang="en-US" sz="900" b="1"/>
+          </a:p>
+        </p:txBody>
+      </p:sp>
+      <p:sp>
+        <p:nvSpPr>
+          <p:cNvPr id="49" name="사각형: 둥근 모서리 12">
+            <a:extLst>
+              <a:ext uri="{FF2B5EF4-FFF2-40B4-BE49-F238E27FC236}">
+                <a16:creationId xmlns:a16="http://schemas.microsoft.com/office/drawing/2014/main" id="{172DB899-E9DE-28D4-6A9F-05757B3CA4E7}"/>
+              </a:ext>
+            </a:extLst>
+          </p:cNvPr>
+          <p:cNvSpPr/>
+          <p:nvPr/>
+        </p:nvSpPr>
+        <p:spPr>
+          <a:xfrm>
+            <a:off x="1320524" y="1651407"/>
+            <a:ext cx="1139438" cy="361356"/>
+          </a:xfrm>
+          <a:prstGeom prst="roundRect">
+            <a:avLst>
+              <a:gd name="adj" fmla="val 14105"/>
+            </a:avLst>
+          </a:prstGeom>
+          <a:solidFill>
+            <a:schemeClr val="bg2">
+              <a:lumMod val="90000"/>
+            </a:schemeClr>
+          </a:solidFill>
+          <a:ln w="12700">
+            <a:headEnd type="none" w="med" len="med"/>
+            <a:tailEnd type="triangle" w="med" len="med"/>
+          </a:ln>
+        </p:spPr>
+        <p:style>
+          <a:lnRef idx="2">
+            <a:schemeClr val="dk1"/>
+          </a:lnRef>
+          <a:fillRef idx="1">
+            <a:schemeClr val="lt1"/>
+          </a:fillRef>
+          <a:effectRef idx="0">
+            <a:schemeClr val="dk1"/>
+          </a:effectRef>
+          <a:fontRef idx="minor">
+            <a:schemeClr val="dk1"/>
+          </a:fontRef>
+        </p:style>
+        <p:txBody>
+          <a:bodyPr rtlCol="0" anchor="ctr"/>
+          <a:lstStyle/>
+          <a:p>
+            <a:pPr algn="ctr"/>
+            <a:r>
+              <a:rPr lang="en-US" altLang="ko-KR" sz="900"/>
+              <a:t>(</a:t>
+            </a:r>
+            <a:r>
+              <a:rPr lang="en-US" altLang="ko-KR" sz="900" u="sng"/>
+              <a:t>llm.ssup2.com</a:t>
+            </a:r>
+            <a:r>
+              <a:rPr lang="en-US" altLang="ko-KR" sz="900"/>
+              <a:t>)</a:t>
+            </a:r>
+          </a:p>
+          <a:p>
+            <a:pPr algn="ctr"/>
+            <a:r>
+              <a:rPr lang="en-US" altLang="ko-KR" sz="900" b="1"/>
+              <a:t>Route Match</a:t>
+            </a:r>
+            <a:endParaRPr lang="ko-KR" altLang="en-US" sz="900" b="1"/>
+          </a:p>
+        </p:txBody>
+      </p:sp>
+      <p:sp>
+        <p:nvSpPr>
+          <p:cNvPr id="50" name="사각형: 둥근 모서리 12">
+            <a:extLst>
+              <a:ext uri="{FF2B5EF4-FFF2-40B4-BE49-F238E27FC236}">
+                <a16:creationId xmlns:a16="http://schemas.microsoft.com/office/drawing/2014/main" id="{C9DE3D1E-7993-BD17-F253-4CEBBB192994}"/>
+              </a:ext>
+            </a:extLst>
+          </p:cNvPr>
+          <p:cNvSpPr/>
+          <p:nvPr/>
+        </p:nvSpPr>
+        <p:spPr>
+          <a:xfrm>
+            <a:off x="2592689" y="1103778"/>
+            <a:ext cx="1247450" cy="361356"/>
+          </a:xfrm>
+          <a:prstGeom prst="roundRect">
+            <a:avLst>
+              <a:gd name="adj" fmla="val 14105"/>
+            </a:avLst>
+          </a:prstGeom>
+          <a:solidFill>
+            <a:schemeClr val="bg1">
+              <a:lumMod val="95000"/>
+            </a:schemeClr>
+          </a:solidFill>
+          <a:ln w="12700">
+            <a:headEnd type="none" w="med" len="med"/>
+            <a:tailEnd type="triangle" w="med" len="med"/>
+          </a:ln>
+        </p:spPr>
+        <p:style>
+          <a:lnRef idx="2">
+            <a:schemeClr val="dk1"/>
+          </a:lnRef>
+          <a:fillRef idx="1">
+            <a:schemeClr val="lt1"/>
+          </a:fillRef>
+          <a:effectRef idx="0">
+            <a:schemeClr val="dk1"/>
+          </a:effectRef>
+          <a:fontRef idx="minor">
+            <a:schemeClr val="dk1"/>
+          </a:fontRef>
+        </p:style>
+        <p:txBody>
+          <a:bodyPr rtlCol="0" anchor="ctr"/>
+          <a:lstStyle/>
+          <a:p>
+            <a:pPr algn="ctr"/>
+            <a:r>
+              <a:rPr lang="en-US" altLang="ko-KR" sz="900" b="1"/>
+              <a:t>Route Table (RDS)</a:t>
+            </a:r>
+            <a:endParaRPr lang="ko-KR" altLang="en-US" sz="900" b="1"/>
+          </a:p>
+        </p:txBody>
+      </p:sp>
+      <p:sp>
+        <p:nvSpPr>
+          <p:cNvPr id="56" name="사각형: 둥근 모서리 12">
+            <a:extLst>
+              <a:ext uri="{FF2B5EF4-FFF2-40B4-BE49-F238E27FC236}">
+                <a16:creationId xmlns:a16="http://schemas.microsoft.com/office/drawing/2014/main" id="{0FD6ABB7-547F-5038-29EA-BC41CBBD0CEA}"/>
+              </a:ext>
+            </a:extLst>
+          </p:cNvPr>
+          <p:cNvSpPr/>
+          <p:nvPr/>
+        </p:nvSpPr>
+        <p:spPr>
+          <a:xfrm>
+            <a:off x="113347" y="559835"/>
+            <a:ext cx="702456" cy="442788"/>
+          </a:xfrm>
+          <a:prstGeom prst="roundRect">
+            <a:avLst>
+              <a:gd name="adj" fmla="val 14105"/>
+            </a:avLst>
+          </a:prstGeom>
+          <a:noFill/>
+          <a:ln w="12700">
+            <a:headEnd type="none" w="med" len="med"/>
+            <a:tailEnd type="triangle" w="med" len="med"/>
+          </a:ln>
+        </p:spPr>
+        <p:style>
+          <a:lnRef idx="2">
+            <a:schemeClr val="dk1"/>
+          </a:lnRef>
+          <a:fillRef idx="1">
+            <a:schemeClr val="lt1"/>
+          </a:fillRef>
+          <a:effectRef idx="0">
+            <a:schemeClr val="dk1"/>
+          </a:effectRef>
+          <a:fontRef idx="minor">
+            <a:schemeClr val="dk1"/>
+          </a:fontRef>
+        </p:style>
+        <p:txBody>
+          <a:bodyPr rtlCol="0" anchor="ctr"/>
+          <a:lstStyle/>
+          <a:p>
+            <a:pPr algn="ctr"/>
+            <a:r>
+              <a:rPr lang="en-US" altLang="ko-KR" sz="900" dirty="0" err="1"/>
+              <a:t>istiod</a:t>
+            </a:r>
+            <a:r>
+              <a:rPr lang="en-US" altLang="ko-KR" sz="900" b="1" dirty="0" err="1"/>
+              <a:t> </a:t>
+            </a:r>
+          </a:p>
+          <a:p>
+            <a:pPr algn="ctr"/>
+            <a:r>
+              <a:rPr lang="en-US" altLang="ko-KR" sz="900" b="1" dirty="0" err="1"/>
+              <a:t>Pod</a:t>
+            </a:r>
+            <a:endParaRPr lang="en-US" altLang="ko-KR" sz="900" dirty="0"/>
+          </a:p>
+        </p:txBody>
+      </p:sp>
+      <p:sp>
+        <p:nvSpPr>
+          <p:cNvPr id="58" name="사각형: 둥근 모서리 70">
+            <a:extLst>
+              <a:ext uri="{FF2B5EF4-FFF2-40B4-BE49-F238E27FC236}">
+                <a16:creationId xmlns:a16="http://schemas.microsoft.com/office/drawing/2014/main" id="{F2C3FAA8-D03F-6A4B-954E-79000F944D60}"/>
+              </a:ext>
+            </a:extLst>
+          </p:cNvPr>
+          <p:cNvSpPr/>
+          <p:nvPr/>
+        </p:nvSpPr>
+        <p:spPr>
+          <a:xfrm>
+            <a:off x="1253533" y="2096925"/>
+            <a:ext cx="4290928" cy="724509"/>
+          </a:xfrm>
+          <a:prstGeom prst="roundRect">
+            <a:avLst>
+              <a:gd name="adj" fmla="val 7237"/>
+            </a:avLst>
+          </a:prstGeom>
+          <a:noFill/>
+          <a:ln w="12700">
+            <a:prstDash val="dash"/>
+            <a:headEnd type="none" w="med" len="med"/>
+            <a:tailEnd type="triangle" w="med" len="med"/>
+          </a:ln>
+        </p:spPr>
+        <p:style>
+          <a:lnRef idx="2">
+            <a:schemeClr val="dk1"/>
+          </a:lnRef>
+          <a:fillRef idx="1">
+            <a:schemeClr val="lt1"/>
+          </a:fillRef>
+          <a:effectRef idx="0">
+            <a:schemeClr val="dk1"/>
+          </a:effectRef>
+          <a:fontRef idx="minor">
+            <a:schemeClr val="dk1"/>
+          </a:fontRef>
+        </p:style>
+        <p:txBody>
+          <a:bodyPr rtlCol="0" anchor="t"/>
+          <a:lstStyle/>
+          <a:p>
+            <a:pPr algn="ctr"/>
+            <a:r>
+              <a:rPr lang="en-US" altLang="ko-KR" sz="1000"/>
+              <a:t>Downstream HTTP Filters</a:t>
+            </a:r>
+            <a:endParaRPr lang="ko-KR" altLang="en-US" sz="1000"/>
+          </a:p>
+        </p:txBody>
+      </p:sp>
+      <p:cxnSp>
+        <p:nvCxnSpPr>
+          <p:cNvPr id="59" name="직선 화살표 연결선 96">
+            <a:extLst>
+              <a:ext uri="{FF2B5EF4-FFF2-40B4-BE49-F238E27FC236}">
+                <a16:creationId xmlns:a16="http://schemas.microsoft.com/office/drawing/2014/main" id="{8B2FBE87-E52A-584C-7338-CBAA21F358B7}"/>
+              </a:ext>
+            </a:extLst>
+          </p:cNvPr>
+          <p:cNvCxnSpPr>
+            <a:cxnSpLocks/>
+            <a:stCxn id="56" idx="3"/>
+            <a:endCxn id="50" idx="0"/>
+          </p:cNvCxnSpPr>
+          <p:nvPr/>
+        </p:nvCxnSpPr>
+        <p:spPr>
+          <a:xfrm>
+            <a:off x="815803" y="781229"/>
+            <a:ext cx="2400611" cy="322549"/>
+          </a:xfrm>
+          <a:prstGeom prst="straightConnector1">
+            <a:avLst/>
+          </a:prstGeom>
+          <a:ln w="12700">
+            <a:solidFill>
+              <a:schemeClr val="tx1"/>
+            </a:solidFill>
+            <a:prstDash val="solid"/>
+            <a:headEnd type="none" w="med" len="med"/>
+            <a:tailEnd type="triangle" w="med" len="med"/>
+          </a:ln>
+        </p:spPr>
+        <p:style>
+          <a:lnRef idx="1">
+            <a:schemeClr val="accent1"/>
+          </a:lnRef>
+          <a:fillRef idx="0">
+            <a:schemeClr val="accent1"/>
+          </a:fillRef>
+          <a:effectRef idx="0">
+            <a:schemeClr val="accent1"/>
+          </a:effectRef>
+          <a:fontRef idx="minor">
+            <a:schemeClr val="tx1"/>
+          </a:fontRef>
+        </p:style>
+      </p:cxnSp>
+      <p:sp>
+        <p:nvSpPr>
+          <p:cNvPr id="70" name="사각형: 둥근 모서리 12">
+            <a:extLst>
+              <a:ext uri="{FF2B5EF4-FFF2-40B4-BE49-F238E27FC236}">
+                <a16:creationId xmlns:a16="http://schemas.microsoft.com/office/drawing/2014/main" id="{5315413D-10A5-BC12-B364-416D00B98218}"/>
+              </a:ext>
+            </a:extLst>
+          </p:cNvPr>
+          <p:cNvSpPr/>
+          <p:nvPr/>
+        </p:nvSpPr>
+        <p:spPr>
+          <a:xfrm>
+            <a:off x="4333401" y="2381537"/>
+            <a:ext cx="1139438" cy="361356"/>
+          </a:xfrm>
+          <a:prstGeom prst="roundRect">
+            <a:avLst>
+              <a:gd name="adj" fmla="val 14105"/>
+            </a:avLst>
+          </a:prstGeom>
+          <a:solidFill>
+            <a:schemeClr val="bg1">
+              <a:lumMod val="95000"/>
+            </a:schemeClr>
+          </a:solidFill>
+          <a:ln w="12700">
+            <a:headEnd type="none" w="med" len="med"/>
+            <a:tailEnd type="triangle" w="med" len="med"/>
+          </a:ln>
+        </p:spPr>
+        <p:style>
+          <a:lnRef idx="2">
+            <a:schemeClr val="dk1"/>
+          </a:lnRef>
+          <a:fillRef idx="1">
+            <a:schemeClr val="lt1"/>
+          </a:fillRef>
+          <a:effectRef idx="0">
+            <a:schemeClr val="dk1"/>
+          </a:effectRef>
+          <a:fontRef idx="minor">
+            <a:schemeClr val="dk1"/>
+          </a:fontRef>
+        </p:style>
+        <p:txBody>
+          <a:bodyPr rtlCol="0" anchor="ctr"/>
+          <a:lstStyle/>
+          <a:p>
+            <a:pPr algn="ctr"/>
+            <a:r>
+              <a:rPr lang="en-US" altLang="ko-KR" sz="900" b="1"/>
+              <a:t>Router</a:t>
+            </a:r>
+            <a:endParaRPr lang="ko-KR" altLang="en-US" sz="900" b="1"/>
+          </a:p>
+        </p:txBody>
+      </p:sp>
+      <p:sp>
+        <p:nvSpPr>
+          <p:cNvPr id="71" name="사각형: 둥근 모서리 12">
+            <a:extLst>
+              <a:ext uri="{FF2B5EF4-FFF2-40B4-BE49-F238E27FC236}">
+                <a16:creationId xmlns:a16="http://schemas.microsoft.com/office/drawing/2014/main" id="{223C893A-20E5-6016-EC01-426D7D06640B}"/>
+              </a:ext>
+            </a:extLst>
+          </p:cNvPr>
+          <p:cNvSpPr/>
+          <p:nvPr/>
+        </p:nvSpPr>
+        <p:spPr>
+          <a:xfrm>
+            <a:off x="1321098" y="2381537"/>
+            <a:ext cx="1139438" cy="361356"/>
+          </a:xfrm>
+          <a:prstGeom prst="roundRect">
+            <a:avLst>
+              <a:gd name="adj" fmla="val 14105"/>
+            </a:avLst>
+          </a:prstGeom>
+          <a:solidFill>
+            <a:schemeClr val="bg1">
+              <a:lumMod val="95000"/>
+            </a:schemeClr>
+          </a:solidFill>
+          <a:ln w="12700">
+            <a:headEnd type="none" w="med" len="med"/>
+            <a:tailEnd type="triangle" w="med" len="med"/>
+          </a:ln>
+        </p:spPr>
+        <p:style>
+          <a:lnRef idx="2">
+            <a:schemeClr val="dk1"/>
+          </a:lnRef>
+          <a:fillRef idx="1">
+            <a:schemeClr val="lt1"/>
+          </a:fillRef>
+          <a:effectRef idx="0">
+            <a:schemeClr val="dk1"/>
+          </a:effectRef>
+          <a:fontRef idx="minor">
+            <a:schemeClr val="dk1"/>
+          </a:fontRef>
+        </p:style>
+        <p:txBody>
+          <a:bodyPr rtlCol="0" anchor="ctr"/>
+          <a:lstStyle/>
+          <a:p>
+            <a:pPr algn="ctr"/>
+            <a:r>
+              <a:rPr lang="en-US" altLang="ko-KR" sz="900" b="1"/>
+              <a:t>ext_authz</a:t>
+            </a:r>
+            <a:endParaRPr lang="ko-KR" altLang="en-US" sz="900" b="1"/>
+          </a:p>
+        </p:txBody>
+      </p:sp>
+      <p:sp>
+        <p:nvSpPr>
+          <p:cNvPr id="73" name="사각형: 둥근 모서리 12">
+            <a:extLst>
+              <a:ext uri="{FF2B5EF4-FFF2-40B4-BE49-F238E27FC236}">
+                <a16:creationId xmlns:a16="http://schemas.microsoft.com/office/drawing/2014/main" id="{352061F0-03E4-0505-6902-11926E9C2F75}"/>
+              </a:ext>
+            </a:extLst>
+          </p:cNvPr>
+          <p:cNvSpPr/>
+          <p:nvPr/>
+        </p:nvSpPr>
+        <p:spPr>
+          <a:xfrm>
+            <a:off x="3015381" y="2381537"/>
+            <a:ext cx="1139438" cy="361356"/>
+          </a:xfrm>
+          <a:prstGeom prst="roundRect">
+            <a:avLst>
+              <a:gd name="adj" fmla="val 14105"/>
+            </a:avLst>
+          </a:prstGeom>
+          <a:solidFill>
+            <a:schemeClr val="bg2">
+              <a:lumMod val="90000"/>
+            </a:schemeClr>
+          </a:solidFill>
+          <a:ln w="12700">
+            <a:headEnd type="none" w="med" len="med"/>
+            <a:tailEnd type="triangle" w="med" len="med"/>
+          </a:ln>
+        </p:spPr>
+        <p:style>
+          <a:lnRef idx="2">
+            <a:schemeClr val="dk1"/>
+          </a:lnRef>
+          <a:fillRef idx="1">
+            <a:schemeClr val="lt1"/>
+          </a:fillRef>
+          <a:effectRef idx="0">
+            <a:schemeClr val="dk1"/>
+          </a:effectRef>
+          <a:fontRef idx="minor">
+            <a:schemeClr val="dk1"/>
+          </a:fontRef>
+        </p:style>
+        <p:txBody>
+          <a:bodyPr rtlCol="0" anchor="ctr"/>
+          <a:lstStyle/>
+          <a:p>
+            <a:pPr algn="ctr"/>
+            <a:r>
+              <a:rPr lang="en-US" altLang="ko-KR" sz="900" b="1"/>
+              <a:t>ext_proc</a:t>
+            </a:r>
+            <a:endParaRPr lang="ko-KR" altLang="en-US" sz="900" b="1"/>
+          </a:p>
+        </p:txBody>
+      </p:sp>
+      <p:cxnSp>
+        <p:nvCxnSpPr>
+          <p:cNvPr id="75" name="직선 화살표 연결선 96">
+            <a:extLst>
+              <a:ext uri="{FF2B5EF4-FFF2-40B4-BE49-F238E27FC236}">
+                <a16:creationId xmlns:a16="http://schemas.microsoft.com/office/drawing/2014/main" id="{47D9B2BA-94AD-F9CF-ED19-547EA432C403}"/>
+              </a:ext>
+            </a:extLst>
+          </p:cNvPr>
+          <p:cNvCxnSpPr>
+            <a:cxnSpLocks/>
+            <a:stCxn id="34" idx="2"/>
+            <a:endCxn id="49" idx="0"/>
+          </p:cNvCxnSpPr>
+          <p:nvPr/>
+        </p:nvCxnSpPr>
+        <p:spPr>
+          <a:xfrm>
+            <a:off x="1889945" y="1470652"/>
+            <a:ext cx="298" cy="180755"/>
+          </a:xfrm>
+          <a:prstGeom prst="straightConnector1">
+            <a:avLst/>
+          </a:prstGeom>
+          <a:ln w="12700">
+            <a:solidFill>
+              <a:srgbClr val="C00000"/>
+            </a:solidFill>
+            <a:prstDash val="solid"/>
+            <a:headEnd type="none" w="med" len="med"/>
+            <a:tailEnd type="triangle" w="med" len="med"/>
+          </a:ln>
+        </p:spPr>
+        <p:style>
+          <a:lnRef idx="1">
+            <a:schemeClr val="accent1"/>
+          </a:lnRef>
+          <a:fillRef idx="0">
+            <a:schemeClr val="accent1"/>
+          </a:fillRef>
+          <a:effectRef idx="0">
+            <a:schemeClr val="accent1"/>
+          </a:effectRef>
+          <a:fontRef idx="minor">
+            <a:schemeClr val="tx1"/>
+          </a:fontRef>
+        </p:style>
+      </p:cxnSp>
+      <p:cxnSp>
+        <p:nvCxnSpPr>
+          <p:cNvPr id="79" name="직선 화살표 연결선 96">
+            <a:extLst>
+              <a:ext uri="{FF2B5EF4-FFF2-40B4-BE49-F238E27FC236}">
+                <a16:creationId xmlns:a16="http://schemas.microsoft.com/office/drawing/2014/main" id="{577D10C3-B6ED-ADD7-D111-A8A6187CD91B}"/>
+              </a:ext>
+            </a:extLst>
+          </p:cNvPr>
+          <p:cNvCxnSpPr>
+            <a:cxnSpLocks/>
+            <a:stCxn id="49" idx="2"/>
+            <a:endCxn id="71" idx="0"/>
+          </p:cNvCxnSpPr>
+          <p:nvPr/>
+        </p:nvCxnSpPr>
+        <p:spPr>
+          <a:xfrm>
+            <a:off x="1890243" y="2012763"/>
+            <a:ext cx="574" cy="368774"/>
+          </a:xfrm>
+          <a:prstGeom prst="straightConnector1">
+            <a:avLst/>
+          </a:prstGeom>
+          <a:ln w="12700">
+            <a:solidFill>
+              <a:srgbClr val="C00000"/>
+            </a:solidFill>
+            <a:prstDash val="solid"/>
+            <a:headEnd type="none" w="med" len="med"/>
+            <a:tailEnd type="triangle" w="med" len="med"/>
+          </a:ln>
+        </p:spPr>
+        <p:style>
+          <a:lnRef idx="1">
+            <a:schemeClr val="accent1"/>
+          </a:lnRef>
+          <a:fillRef idx="0">
+            <a:schemeClr val="accent1"/>
+          </a:fillRef>
+          <a:effectRef idx="0">
+            <a:schemeClr val="accent1"/>
+          </a:effectRef>
+          <a:fontRef idx="minor">
+            <a:schemeClr val="tx1"/>
+          </a:fontRef>
+        </p:style>
+      </p:cxnSp>
+      <p:cxnSp>
+        <p:nvCxnSpPr>
+          <p:cNvPr id="82" name="직선 화살표 연결선 96">
+            <a:extLst>
+              <a:ext uri="{FF2B5EF4-FFF2-40B4-BE49-F238E27FC236}">
+                <a16:creationId xmlns:a16="http://schemas.microsoft.com/office/drawing/2014/main" id="{F360DB25-DF5A-D6D9-311B-25375911DAAD}"/>
+              </a:ext>
+            </a:extLst>
+          </p:cNvPr>
+          <p:cNvCxnSpPr>
+            <a:cxnSpLocks/>
+            <a:stCxn id="71" idx="3"/>
+            <a:endCxn id="73" idx="1"/>
+          </p:cNvCxnSpPr>
+          <p:nvPr/>
+        </p:nvCxnSpPr>
+        <p:spPr>
+          <a:xfrm>
+            <a:off x="2460536" y="2562215"/>
+            <a:ext cx="554845" cy="0"/>
+          </a:xfrm>
+          <a:prstGeom prst="straightConnector1">
+            <a:avLst/>
+          </a:prstGeom>
+          <a:ln w="12700">
+            <a:solidFill>
+              <a:srgbClr val="C00000"/>
+            </a:solidFill>
+            <a:prstDash val="solid"/>
+            <a:headEnd type="none" w="med" len="med"/>
+            <a:tailEnd type="triangle" w="med" len="med"/>
+          </a:ln>
+        </p:spPr>
+        <p:style>
+          <a:lnRef idx="1">
+            <a:schemeClr val="accent1"/>
+          </a:lnRef>
+          <a:fillRef idx="0">
+            <a:schemeClr val="accent1"/>
+          </a:fillRef>
+          <a:effectRef idx="0">
+            <a:schemeClr val="accent1"/>
+          </a:effectRef>
+          <a:fontRef idx="minor">
+            <a:schemeClr val="tx1"/>
+          </a:fontRef>
+        </p:style>
+      </p:cxnSp>
+      <p:cxnSp>
+        <p:nvCxnSpPr>
+          <p:cNvPr id="100" name="직선 화살표 연결선 96">
+            <a:extLst>
+              <a:ext uri="{FF2B5EF4-FFF2-40B4-BE49-F238E27FC236}">
+                <a16:creationId xmlns:a16="http://schemas.microsoft.com/office/drawing/2014/main" id="{FA920C3C-9732-DD1F-70D9-1F20A238C11A}"/>
+              </a:ext>
+            </a:extLst>
+          </p:cNvPr>
+          <p:cNvCxnSpPr>
+            <a:cxnSpLocks/>
+            <a:stCxn id="73" idx="3"/>
+            <a:endCxn id="70" idx="1"/>
+          </p:cNvCxnSpPr>
+          <p:nvPr/>
+        </p:nvCxnSpPr>
+        <p:spPr>
+          <a:xfrm>
+            <a:off x="4154819" y="2562215"/>
+            <a:ext cx="178582" cy="0"/>
+          </a:xfrm>
+          <a:prstGeom prst="straightConnector1">
+            <a:avLst/>
+          </a:prstGeom>
+          <a:ln w="12700">
+            <a:solidFill>
+              <a:srgbClr val="C00000"/>
+            </a:solidFill>
+            <a:prstDash val="solid"/>
+            <a:headEnd type="none" w="med" len="med"/>
+            <a:tailEnd type="triangle" w="med" len="med"/>
+          </a:ln>
+        </p:spPr>
+        <p:style>
+          <a:lnRef idx="1">
+            <a:schemeClr val="accent1"/>
+          </a:lnRef>
+          <a:fillRef idx="0">
+            <a:schemeClr val="accent1"/>
+          </a:fillRef>
+          <a:effectRef idx="0">
+            <a:schemeClr val="accent1"/>
+          </a:effectRef>
+          <a:fontRef idx="minor">
+            <a:schemeClr val="tx1"/>
+          </a:fontRef>
+        </p:style>
+      </p:cxnSp>
+      <p:sp>
+        <p:nvSpPr>
+          <p:cNvPr id="106" name="사각형: 둥근 모서리 12">
+            <a:extLst>
+              <a:ext uri="{FF2B5EF4-FFF2-40B4-BE49-F238E27FC236}">
+                <a16:creationId xmlns:a16="http://schemas.microsoft.com/office/drawing/2014/main" id="{C0172A54-F113-7F24-F082-ABC1D2D40FD4}"/>
+              </a:ext>
+            </a:extLst>
+          </p:cNvPr>
+          <p:cNvSpPr/>
+          <p:nvPr/>
+        </p:nvSpPr>
+        <p:spPr>
+          <a:xfrm>
+            <a:off x="1560846" y="2932426"/>
+            <a:ext cx="1931526" cy="361356"/>
+          </a:xfrm>
+          <a:prstGeom prst="roundRect">
+            <a:avLst>
+              <a:gd name="adj" fmla="val 14105"/>
+            </a:avLst>
+          </a:prstGeom>
+          <a:solidFill>
+            <a:schemeClr val="bg2">
+              <a:lumMod val="90000"/>
+            </a:schemeClr>
+          </a:solidFill>
+          <a:ln w="12700">
+            <a:headEnd type="none" w="med" len="med"/>
+            <a:tailEnd type="triangle" w="med" len="med"/>
+          </a:ln>
+        </p:spPr>
+        <p:style>
+          <a:lnRef idx="2">
+            <a:schemeClr val="dk1"/>
+          </a:lnRef>
+          <a:fillRef idx="1">
+            <a:schemeClr val="lt1"/>
+          </a:fillRef>
+          <a:effectRef idx="0">
+            <a:schemeClr val="dk1"/>
+          </a:effectRef>
+          <a:fontRef idx="minor">
+            <a:schemeClr val="dk1"/>
+          </a:fontRef>
+        </p:style>
+        <p:txBody>
+          <a:bodyPr rtlCol="0" anchor="ctr"/>
+          <a:lstStyle/>
+          <a:p>
+            <a:pPr algn="ctr"/>
+            <a:r>
+              <a:rPr lang="en-US" altLang="ko-KR" sz="900"/>
+              <a:t>x-gateway-destination-endpoint</a:t>
+            </a:r>
+          </a:p>
+          <a:p>
+            <a:pPr algn="ctr"/>
+            <a:r>
+              <a:rPr lang="en-US" altLang="ko-KR" sz="900" b="1"/>
+              <a:t>Request Header</a:t>
+            </a:r>
+          </a:p>
+        </p:txBody>
+      </p:sp>
+      <p:sp>
+        <p:nvSpPr>
+          <p:cNvPr id="107" name="사각형: 둥근 모서리 12">
+            <a:extLst>
+              <a:ext uri="{FF2B5EF4-FFF2-40B4-BE49-F238E27FC236}">
+                <a16:creationId xmlns:a16="http://schemas.microsoft.com/office/drawing/2014/main" id="{939F494B-9650-BDF2-4EB0-082723ADD4FF}"/>
+              </a:ext>
+            </a:extLst>
+          </p:cNvPr>
+          <p:cNvSpPr/>
+          <p:nvPr/>
+        </p:nvSpPr>
+        <p:spPr>
+          <a:xfrm>
+            <a:off x="3654042" y="2932426"/>
+            <a:ext cx="1434829" cy="361356"/>
+          </a:xfrm>
+          <a:prstGeom prst="roundRect">
+            <a:avLst>
+              <a:gd name="adj" fmla="val 14105"/>
+            </a:avLst>
+          </a:prstGeom>
+          <a:solidFill>
+            <a:schemeClr val="bg2">
+              <a:lumMod val="90000"/>
+            </a:schemeClr>
+          </a:solidFill>
+          <a:ln w="12700">
+            <a:headEnd type="none" w="med" len="med"/>
+            <a:tailEnd type="triangle" w="med" len="med"/>
+          </a:ln>
+        </p:spPr>
+        <p:style>
+          <a:lnRef idx="2">
+            <a:schemeClr val="dk1"/>
+          </a:lnRef>
+          <a:fillRef idx="1">
+            <a:schemeClr val="lt1"/>
+          </a:fillRef>
+          <a:effectRef idx="0">
+            <a:schemeClr val="dk1"/>
+          </a:effectRef>
+          <a:fontRef idx="minor">
+            <a:schemeClr val="dk1"/>
+          </a:fontRef>
+        </p:style>
+        <p:txBody>
+          <a:bodyPr rtlCol="0" anchor="ctr"/>
+          <a:lstStyle/>
+          <a:p>
+            <a:pPr algn="ctr"/>
+            <a:r>
+              <a:rPr lang="en-US" altLang="ko-KR" sz="900"/>
+              <a:t>envoy.lb namespace</a:t>
+            </a:r>
+          </a:p>
+          <a:p>
+            <a:pPr algn="ctr"/>
+            <a:r>
+              <a:rPr lang="en-US" altLang="ko-KR" sz="900" b="1"/>
+              <a:t>Dynamic Metadata</a:t>
+            </a:r>
+          </a:p>
+        </p:txBody>
+      </p:sp>
+      <p:cxnSp>
+        <p:nvCxnSpPr>
+          <p:cNvPr id="108" name="직선 화살표 연결선 96">
+            <a:extLst>
+              <a:ext uri="{FF2B5EF4-FFF2-40B4-BE49-F238E27FC236}">
+                <a16:creationId xmlns:a16="http://schemas.microsoft.com/office/drawing/2014/main" id="{E4609D99-2A82-76C8-1DB3-06D84297A04A}"/>
+              </a:ext>
+            </a:extLst>
+          </p:cNvPr>
+          <p:cNvCxnSpPr>
+            <a:cxnSpLocks/>
+            <a:stCxn id="73" idx="2"/>
+            <a:endCxn id="106" idx="0"/>
+          </p:cNvCxnSpPr>
+          <p:nvPr/>
+        </p:nvCxnSpPr>
+        <p:spPr>
+          <a:xfrm flipH="1">
+            <a:off x="2526609" y="2742893"/>
+            <a:ext cx="1058491" cy="189533"/>
+          </a:xfrm>
+          <a:prstGeom prst="straightConnector1">
+            <a:avLst/>
+          </a:prstGeom>
+          <a:ln w="12700">
+            <a:solidFill>
+              <a:schemeClr val="tx2"/>
+            </a:solidFill>
+            <a:prstDash val="solid"/>
+            <a:headEnd type="none" w="med" len="med"/>
+            <a:tailEnd type="triangle" w="med" len="med"/>
+          </a:ln>
+        </p:spPr>
+        <p:style>
+          <a:lnRef idx="1">
+            <a:schemeClr val="accent1"/>
+          </a:lnRef>
+          <a:fillRef idx="0">
+            <a:schemeClr val="accent1"/>
+          </a:fillRef>
+          <a:effectRef idx="0">
+            <a:schemeClr val="accent1"/>
+          </a:effectRef>
+          <a:fontRef idx="minor">
+            <a:schemeClr val="tx1"/>
+          </a:fontRef>
+        </p:style>
+      </p:cxnSp>
+      <p:cxnSp>
+        <p:nvCxnSpPr>
+          <p:cNvPr id="111" name="직선 화살표 연결선 96">
+            <a:extLst>
+              <a:ext uri="{FF2B5EF4-FFF2-40B4-BE49-F238E27FC236}">
+                <a16:creationId xmlns:a16="http://schemas.microsoft.com/office/drawing/2014/main" id="{F8F6FCBC-F0DB-FF98-6FB0-84231A4FF929}"/>
+              </a:ext>
+            </a:extLst>
+          </p:cNvPr>
+          <p:cNvCxnSpPr>
+            <a:cxnSpLocks/>
+            <a:stCxn id="73" idx="2"/>
+            <a:endCxn id="107" idx="0"/>
+          </p:cNvCxnSpPr>
+          <p:nvPr/>
+        </p:nvCxnSpPr>
+        <p:spPr>
+          <a:xfrm>
+            <a:off x="3585100" y="2742893"/>
+            <a:ext cx="786357" cy="189533"/>
+          </a:xfrm>
+          <a:prstGeom prst="straightConnector1">
+            <a:avLst/>
+          </a:prstGeom>
+          <a:ln w="12700">
+            <a:solidFill>
+              <a:schemeClr val="tx2"/>
+            </a:solidFill>
+            <a:prstDash val="solid"/>
+            <a:headEnd type="none" w="med" len="med"/>
+            <a:tailEnd type="triangle" w="med" len="med"/>
+          </a:ln>
+        </p:spPr>
+        <p:style>
+          <a:lnRef idx="1">
+            <a:schemeClr val="accent1"/>
+          </a:lnRef>
+          <a:fillRef idx="0">
+            <a:schemeClr val="accent1"/>
+          </a:fillRef>
+          <a:effectRef idx="0">
+            <a:schemeClr val="accent1"/>
+          </a:effectRef>
+          <a:fontRef idx="minor">
+            <a:schemeClr val="tx1"/>
+          </a:fontRef>
+        </p:style>
+      </p:cxnSp>
+      <p:sp>
+        <p:nvSpPr>
+          <p:cNvPr id="116" name="사각형: 둥근 모서리 12">
+            <a:extLst>
+              <a:ext uri="{FF2B5EF4-FFF2-40B4-BE49-F238E27FC236}">
+                <a16:creationId xmlns:a16="http://schemas.microsoft.com/office/drawing/2014/main" id="{D23E6738-BFF7-0828-65E2-2C3CABBFBD47}"/>
+              </a:ext>
+            </a:extLst>
+          </p:cNvPr>
+          <p:cNvSpPr/>
+          <p:nvPr/>
+        </p:nvSpPr>
+        <p:spPr>
+          <a:xfrm>
+            <a:off x="5755515" y="1063062"/>
+            <a:ext cx="1515148" cy="442788"/>
+          </a:xfrm>
+          <a:prstGeom prst="roundRect">
+            <a:avLst>
+              <a:gd name="adj" fmla="val 14105"/>
+            </a:avLst>
+          </a:prstGeom>
+          <a:solidFill>
+            <a:schemeClr val="bg2">
+              <a:lumMod val="90000"/>
+            </a:schemeClr>
+          </a:solidFill>
+          <a:ln w="12700">
+            <a:headEnd type="none" w="med" len="med"/>
+            <a:tailEnd type="triangle" w="med" len="med"/>
+          </a:ln>
+        </p:spPr>
+        <p:style>
+          <a:lnRef idx="2">
+            <a:schemeClr val="dk1"/>
+          </a:lnRef>
+          <a:fillRef idx="1">
+            <a:schemeClr val="lt1"/>
+          </a:fillRef>
+          <a:effectRef idx="0">
+            <a:schemeClr val="dk1"/>
+          </a:effectRef>
+          <a:fontRef idx="minor">
+            <a:schemeClr val="dk1"/>
+          </a:fontRef>
+        </p:style>
+        <p:txBody>
+          <a:bodyPr rtlCol="0" anchor="ctr"/>
+          <a:lstStyle/>
+          <a:p>
+            <a:pPr algn="ctr"/>
+            <a:r>
+              <a:rPr lang="en-US" altLang="ko-KR" sz="900"/>
+              <a:t>Endpoint Picker</a:t>
+            </a:r>
+          </a:p>
+          <a:p>
+            <a:pPr algn="ctr"/>
+            <a:r>
+              <a:rPr lang="en-US" altLang="ko-KR" sz="900" b="1"/>
+              <a:t>Cluster</a:t>
+            </a:r>
+            <a:endParaRPr lang="ko-KR" altLang="en-US" sz="900" b="1"/>
+          </a:p>
+        </p:txBody>
+      </p:sp>
+      <p:sp>
+        <p:nvSpPr>
+          <p:cNvPr id="117" name="사각형: 둥근 모서리 12">
+            <a:extLst>
+              <a:ext uri="{FF2B5EF4-FFF2-40B4-BE49-F238E27FC236}">
+                <a16:creationId xmlns:a16="http://schemas.microsoft.com/office/drawing/2014/main" id="{A5189D0E-E063-BD36-1C9C-7CD0A432EABD}"/>
+              </a:ext>
+            </a:extLst>
+          </p:cNvPr>
+          <p:cNvSpPr/>
+          <p:nvPr/>
+        </p:nvSpPr>
+        <p:spPr>
+          <a:xfrm>
+            <a:off x="5755516" y="1692013"/>
+            <a:ext cx="1515148" cy="442788"/>
+          </a:xfrm>
+          <a:prstGeom prst="roundRect">
+            <a:avLst>
+              <a:gd name="adj" fmla="val 14105"/>
+            </a:avLst>
+          </a:prstGeom>
+          <a:solidFill>
+            <a:schemeClr val="bg2">
+              <a:lumMod val="90000"/>
+            </a:schemeClr>
+          </a:solidFill>
+          <a:ln w="12700">
+            <a:headEnd type="none" w="med" len="med"/>
+            <a:tailEnd type="triangle" w="med" len="med"/>
+          </a:ln>
+        </p:spPr>
+        <p:style>
+          <a:lnRef idx="2">
+            <a:schemeClr val="dk1"/>
+          </a:lnRef>
+          <a:fillRef idx="1">
+            <a:schemeClr val="lt1"/>
+          </a:fillRef>
+          <a:effectRef idx="0">
+            <a:schemeClr val="dk1"/>
+          </a:effectRef>
+          <a:fontRef idx="minor">
+            <a:schemeClr val="dk1"/>
+          </a:fontRef>
+        </p:style>
+        <p:txBody>
+          <a:bodyPr rtlCol="0" anchor="ctr"/>
+          <a:lstStyle/>
+          <a:p>
+            <a:pPr algn="ctr"/>
+            <a:r>
+              <a:rPr lang="en-US" altLang="ko-KR" sz="900"/>
+              <a:t>Endpoint Picker</a:t>
+            </a:r>
+            <a:r>
+              <a:rPr lang="en-US" altLang="ko-KR" sz="900" b="1"/>
+              <a:t> </a:t>
+            </a:r>
+            <a:br>
+              <a:rPr lang="en-US" altLang="ko-KR" sz="900" b="1"/>
+            </a:br>
+            <a:r>
+              <a:rPr lang="en-US" altLang="ko-KR" sz="900"/>
+              <a:t>(</a:t>
+            </a:r>
+            <a:r>
+              <a:rPr lang="en-US" altLang="ko-KR" sz="900" u="sng"/>
+              <a:t>TLS via DestinationRule</a:t>
+            </a:r>
+            <a:r>
+              <a:rPr lang="en-US" altLang="ko-KR" sz="900"/>
+              <a:t>)</a:t>
+            </a:r>
+            <a:endParaRPr lang="en-US" altLang="ko-KR" sz="900" b="1"/>
+          </a:p>
+          <a:p>
+            <a:pPr algn="ctr"/>
+            <a:r>
+              <a:rPr lang="en-US" altLang="ko-KR" sz="900" b="1"/>
+              <a:t>Upstream Connection</a:t>
+            </a:r>
+          </a:p>
+        </p:txBody>
+      </p:sp>
+      <p:sp>
+        <p:nvSpPr>
+          <p:cNvPr id="119" name="사각형: 둥근 모서리 12">
+            <a:extLst>
+              <a:ext uri="{FF2B5EF4-FFF2-40B4-BE49-F238E27FC236}">
+                <a16:creationId xmlns:a16="http://schemas.microsoft.com/office/drawing/2014/main" id="{935EA965-18F1-68C5-2143-26C6623CFB55}"/>
+              </a:ext>
+            </a:extLst>
+          </p:cNvPr>
+          <p:cNvSpPr/>
+          <p:nvPr/>
+        </p:nvSpPr>
+        <p:spPr>
+          <a:xfrm>
+            <a:off x="5756470" y="2571070"/>
+            <a:ext cx="1530675" cy="442788"/>
+          </a:xfrm>
+          <a:prstGeom prst="roundRect">
+            <a:avLst>
+              <a:gd name="adj" fmla="val 14105"/>
+            </a:avLst>
+          </a:prstGeom>
+          <a:solidFill>
+            <a:schemeClr val="bg1">
+              <a:lumMod val="95000"/>
+            </a:schemeClr>
+          </a:solidFill>
+          <a:ln w="12700">
+            <a:headEnd type="none" w="med" len="med"/>
+            <a:tailEnd type="triangle" w="med" len="med"/>
+          </a:ln>
+        </p:spPr>
+        <p:style>
+          <a:lnRef idx="2">
+            <a:schemeClr val="dk1"/>
+          </a:lnRef>
+          <a:fillRef idx="1">
+            <a:schemeClr val="lt1"/>
+          </a:fillRef>
+          <a:effectRef idx="0">
+            <a:schemeClr val="dk1"/>
+          </a:effectRef>
+          <a:fontRef idx="minor">
+            <a:schemeClr val="dk1"/>
+          </a:fontRef>
+        </p:style>
+        <p:txBody>
+          <a:bodyPr rtlCol="0" anchor="ctr"/>
+          <a:lstStyle/>
+          <a:p>
+            <a:pPr algn="ctr"/>
+            <a:r>
+              <a:rPr lang="en-US" altLang="ko-KR" sz="900"/>
+              <a:t>Model Pod</a:t>
+            </a:r>
+          </a:p>
+          <a:p>
+            <a:pPr algn="ctr"/>
+            <a:r>
+              <a:rPr lang="en-US" altLang="ko-KR" sz="900" b="1"/>
+              <a:t>Upstream Connection</a:t>
+            </a:r>
+          </a:p>
+        </p:txBody>
+      </p:sp>
+      <p:cxnSp>
+        <p:nvCxnSpPr>
+          <p:cNvPr id="130" name="직선 화살표 연결선 96">
+            <a:extLst>
+              <a:ext uri="{FF2B5EF4-FFF2-40B4-BE49-F238E27FC236}">
+                <a16:creationId xmlns:a16="http://schemas.microsoft.com/office/drawing/2014/main" id="{5C030636-336E-65B0-4DA4-860436253631}"/>
+              </a:ext>
+            </a:extLst>
+          </p:cNvPr>
+          <p:cNvCxnSpPr>
+            <a:cxnSpLocks/>
+            <a:stCxn id="73" idx="0"/>
+            <a:endCxn id="116" idx="1"/>
+          </p:cNvCxnSpPr>
+          <p:nvPr/>
+        </p:nvCxnSpPr>
+        <p:spPr>
+          <a:xfrm flipV="1">
+            <a:off x="3585100" y="1284456"/>
+            <a:ext cx="2170415" cy="1097081"/>
+          </a:xfrm>
+          <a:prstGeom prst="straightConnector1">
+            <a:avLst/>
+          </a:prstGeom>
+          <a:ln w="12700">
+            <a:solidFill>
+              <a:schemeClr val="tx2"/>
+            </a:solidFill>
+            <a:prstDash val="solid"/>
+            <a:headEnd type="none" w="med" len="med"/>
+            <a:tailEnd type="triangle" w="med" len="med"/>
+          </a:ln>
+        </p:spPr>
+        <p:style>
+          <a:lnRef idx="1">
+            <a:schemeClr val="accent1"/>
+          </a:lnRef>
+          <a:fillRef idx="0">
+            <a:schemeClr val="accent1"/>
+          </a:fillRef>
+          <a:effectRef idx="0">
+            <a:schemeClr val="accent1"/>
+          </a:effectRef>
+          <a:fontRef idx="minor">
+            <a:schemeClr val="tx1"/>
+          </a:fontRef>
+        </p:style>
+      </p:cxnSp>
+      <p:cxnSp>
+        <p:nvCxnSpPr>
+          <p:cNvPr id="134" name="직선 화살표 연결선 96">
+            <a:extLst>
+              <a:ext uri="{FF2B5EF4-FFF2-40B4-BE49-F238E27FC236}">
+                <a16:creationId xmlns:a16="http://schemas.microsoft.com/office/drawing/2014/main" id="{96354647-FE9B-AB90-C25E-91B2B43D6C48}"/>
+              </a:ext>
+            </a:extLst>
+          </p:cNvPr>
+          <p:cNvCxnSpPr>
+            <a:cxnSpLocks/>
+            <a:stCxn id="116" idx="2"/>
+            <a:endCxn id="117" idx="0"/>
+          </p:cNvCxnSpPr>
+          <p:nvPr/>
+        </p:nvCxnSpPr>
+        <p:spPr>
+          <a:xfrm>
+            <a:off x="6513089" y="1505850"/>
+            <a:ext cx="1" cy="186163"/>
+          </a:xfrm>
+          <a:prstGeom prst="straightConnector1">
+            <a:avLst/>
+          </a:prstGeom>
+          <a:ln w="12700">
+            <a:solidFill>
+              <a:schemeClr val="tx2"/>
+            </a:solidFill>
+            <a:prstDash val="solid"/>
+            <a:headEnd type="none" w="med" len="med"/>
+            <a:tailEnd type="triangle" w="med" len="med"/>
+          </a:ln>
+        </p:spPr>
+        <p:style>
+          <a:lnRef idx="1">
+            <a:schemeClr val="accent1"/>
+          </a:lnRef>
+          <a:fillRef idx="0">
+            <a:schemeClr val="accent1"/>
+          </a:fillRef>
+          <a:effectRef idx="0">
+            <a:schemeClr val="accent1"/>
+          </a:effectRef>
+          <a:fontRef idx="minor">
+            <a:schemeClr val="tx1"/>
+          </a:fontRef>
+        </p:style>
+      </p:cxnSp>
+      <p:sp>
+        <p:nvSpPr>
+          <p:cNvPr id="143" name="사각형: 둥근 모서리 12">
+            <a:extLst>
+              <a:ext uri="{FF2B5EF4-FFF2-40B4-BE49-F238E27FC236}">
+                <a16:creationId xmlns:a16="http://schemas.microsoft.com/office/drawing/2014/main" id="{3FC88BED-63DE-FDFF-03E1-663571AD344A}"/>
+              </a:ext>
+            </a:extLst>
+          </p:cNvPr>
+          <p:cNvSpPr/>
+          <p:nvPr/>
+        </p:nvSpPr>
+        <p:spPr>
+          <a:xfrm>
+            <a:off x="5756515" y="3202939"/>
+            <a:ext cx="1530674" cy="442787"/>
+          </a:xfrm>
+          <a:prstGeom prst="roundRect">
+            <a:avLst>
+              <a:gd name="adj" fmla="val 14105"/>
+            </a:avLst>
+          </a:prstGeom>
+          <a:solidFill>
+            <a:schemeClr val="bg2">
+              <a:lumMod val="90000"/>
+            </a:schemeClr>
+          </a:solidFill>
+          <a:ln w="12700">
+            <a:headEnd type="none" w="med" len="med"/>
+            <a:tailEnd type="triangle" w="med" len="med"/>
+          </a:ln>
+        </p:spPr>
+        <p:style>
+          <a:lnRef idx="2">
+            <a:schemeClr val="dk1"/>
+          </a:lnRef>
+          <a:fillRef idx="1">
+            <a:schemeClr val="lt1"/>
+          </a:fillRef>
+          <a:effectRef idx="0">
+            <a:schemeClr val="dk1"/>
+          </a:effectRef>
+          <a:fontRef idx="minor">
+            <a:schemeClr val="dk1"/>
+          </a:fontRef>
+        </p:style>
+        <p:txBody>
+          <a:bodyPr rtlCol="0" anchor="ctr"/>
+          <a:lstStyle/>
+          <a:p>
+            <a:pPr algn="ctr"/>
+            <a:r>
+              <a:rPr lang="en-US" altLang="ko-KR" sz="900"/>
+              <a:t>Shadow Service</a:t>
+            </a:r>
+          </a:p>
+          <a:p>
+            <a:pPr algn="ctr"/>
+            <a:r>
+              <a:rPr lang="en-US" altLang="ko-KR" sz="900"/>
+              <a:t>(</a:t>
+            </a:r>
+            <a:r>
+              <a:rPr lang="en-US" altLang="ko-KR" sz="900" u="sng"/>
+              <a:t>Override Host LB Policy</a:t>
+            </a:r>
+            <a:r>
+              <a:rPr lang="en-US" altLang="ko-KR" sz="900"/>
+              <a:t>)</a:t>
+            </a:r>
+            <a:br>
+              <a:rPr lang="en-US" altLang="ko-KR" sz="900"/>
+            </a:br>
+            <a:r>
+              <a:rPr lang="en-US" altLang="ko-KR" sz="900"/>
+              <a:t> </a:t>
+            </a:r>
+            <a:r>
+              <a:rPr lang="en-US" altLang="ko-KR" sz="900" b="1"/>
+              <a:t>Cluster</a:t>
+            </a:r>
+          </a:p>
+        </p:txBody>
+      </p:sp>
+      <p:cxnSp>
+        <p:nvCxnSpPr>
+          <p:cNvPr id="144" name="직선 화살표 연결선 96">
+            <a:extLst>
+              <a:ext uri="{FF2B5EF4-FFF2-40B4-BE49-F238E27FC236}">
+                <a16:creationId xmlns:a16="http://schemas.microsoft.com/office/drawing/2014/main" id="{1BDAB482-DCD1-9CA0-46C1-270F1AA8AAD6}"/>
+              </a:ext>
+            </a:extLst>
+          </p:cNvPr>
+          <p:cNvCxnSpPr>
+            <a:cxnSpLocks/>
+            <a:stCxn id="107" idx="3"/>
+            <a:endCxn id="143" idx="1"/>
+          </p:cNvCxnSpPr>
+          <p:nvPr/>
+        </p:nvCxnSpPr>
+        <p:spPr>
+          <a:xfrm>
+            <a:off x="5088871" y="3113104"/>
+            <a:ext cx="667644" cy="311229"/>
+          </a:xfrm>
+          <a:prstGeom prst="straightConnector1">
+            <a:avLst/>
+          </a:prstGeom>
+          <a:ln w="12700">
+            <a:solidFill>
+              <a:schemeClr val="tx2"/>
+            </a:solidFill>
+            <a:prstDash val="solid"/>
+            <a:headEnd type="none" w="med" len="med"/>
+            <a:tailEnd type="triangle" w="med" len="med"/>
+          </a:ln>
+        </p:spPr>
+        <p:style>
+          <a:lnRef idx="1">
+            <a:schemeClr val="accent1"/>
+          </a:lnRef>
+          <a:fillRef idx="0">
+            <a:schemeClr val="accent1"/>
+          </a:fillRef>
+          <a:effectRef idx="0">
+            <a:schemeClr val="accent1"/>
+          </a:effectRef>
+          <a:fontRef idx="minor">
+            <a:schemeClr val="tx1"/>
+          </a:fontRef>
+        </p:style>
+      </p:cxnSp>
+      <p:cxnSp>
+        <p:nvCxnSpPr>
+          <p:cNvPr id="147" name="직선 화살표 연결선 96">
+            <a:extLst>
+              <a:ext uri="{FF2B5EF4-FFF2-40B4-BE49-F238E27FC236}">
+                <a16:creationId xmlns:a16="http://schemas.microsoft.com/office/drawing/2014/main" id="{0102F148-590B-4E1A-D3FD-8DA203B48F1D}"/>
+              </a:ext>
+            </a:extLst>
+          </p:cNvPr>
+          <p:cNvCxnSpPr>
+            <a:cxnSpLocks/>
+            <a:stCxn id="106" idx="2"/>
+            <a:endCxn id="143" idx="1"/>
+          </p:cNvCxnSpPr>
+          <p:nvPr/>
+        </p:nvCxnSpPr>
+        <p:spPr>
+          <a:xfrm>
+            <a:off x="2526609" y="3293782"/>
+            <a:ext cx="3229906" cy="130551"/>
+          </a:xfrm>
+          <a:prstGeom prst="straightConnector1">
+            <a:avLst/>
+          </a:prstGeom>
+          <a:ln w="12700">
+            <a:solidFill>
+              <a:schemeClr val="tx2"/>
+            </a:solidFill>
+            <a:prstDash val="solid"/>
+            <a:headEnd type="none" w="med" len="med"/>
+            <a:tailEnd type="triangle" w="med" len="med"/>
+          </a:ln>
+        </p:spPr>
+        <p:style>
+          <a:lnRef idx="1">
+            <a:schemeClr val="accent1"/>
+          </a:lnRef>
+          <a:fillRef idx="0">
+            <a:schemeClr val="accent1"/>
+          </a:fillRef>
+          <a:effectRef idx="0">
+            <a:schemeClr val="accent1"/>
+          </a:effectRef>
+          <a:fontRef idx="minor">
+            <a:schemeClr val="tx1"/>
+          </a:fontRef>
+        </p:style>
+      </p:cxnSp>
+      <p:cxnSp>
+        <p:nvCxnSpPr>
+          <p:cNvPr id="150" name="직선 화살표 연결선 96">
+            <a:extLst>
+              <a:ext uri="{FF2B5EF4-FFF2-40B4-BE49-F238E27FC236}">
+                <a16:creationId xmlns:a16="http://schemas.microsoft.com/office/drawing/2014/main" id="{4A73A2D2-5B53-0E8D-32FD-2A261FD7BB3E}"/>
+              </a:ext>
+            </a:extLst>
+          </p:cNvPr>
+          <p:cNvCxnSpPr>
+            <a:cxnSpLocks/>
+            <a:stCxn id="70" idx="2"/>
+            <a:endCxn id="143" idx="1"/>
+          </p:cNvCxnSpPr>
+          <p:nvPr/>
+        </p:nvCxnSpPr>
+        <p:spPr>
+          <a:xfrm>
+            <a:off x="4903120" y="2742893"/>
+            <a:ext cx="853395" cy="681440"/>
+          </a:xfrm>
+          <a:prstGeom prst="straightConnector1">
+            <a:avLst/>
+          </a:prstGeom>
+          <a:ln w="12700">
+            <a:solidFill>
+              <a:srgbClr val="C00000"/>
+            </a:solidFill>
+            <a:prstDash val="solid"/>
+            <a:headEnd type="none" w="med" len="med"/>
+            <a:tailEnd type="triangle" w="med" len="med"/>
+          </a:ln>
+        </p:spPr>
+        <p:style>
+          <a:lnRef idx="1">
+            <a:schemeClr val="accent1"/>
+          </a:lnRef>
+          <a:fillRef idx="0">
+            <a:schemeClr val="accent1"/>
+          </a:fillRef>
+          <a:effectRef idx="0">
+            <a:schemeClr val="accent1"/>
+          </a:effectRef>
+          <a:fontRef idx="minor">
+            <a:schemeClr val="tx1"/>
+          </a:fontRef>
+        </p:style>
+      </p:cxnSp>
+      <p:cxnSp>
+        <p:nvCxnSpPr>
+          <p:cNvPr id="164" name="직선 화살표 연결선 96">
+            <a:extLst>
+              <a:ext uri="{FF2B5EF4-FFF2-40B4-BE49-F238E27FC236}">
+                <a16:creationId xmlns:a16="http://schemas.microsoft.com/office/drawing/2014/main" id="{8E6F03AE-C88C-2A8E-6430-30F9B814EFBF}"/>
+              </a:ext>
+            </a:extLst>
+          </p:cNvPr>
+          <p:cNvCxnSpPr>
+            <a:cxnSpLocks/>
+            <a:stCxn id="143" idx="0"/>
+            <a:endCxn id="119" idx="2"/>
+          </p:cNvCxnSpPr>
+          <p:nvPr/>
+        </p:nvCxnSpPr>
+        <p:spPr>
+          <a:xfrm flipH="1" flipV="1">
+            <a:off x="6521808" y="3013858"/>
+            <a:ext cx="44" cy="189081"/>
+          </a:xfrm>
+          <a:prstGeom prst="straightConnector1">
+            <a:avLst/>
+          </a:prstGeom>
+          <a:ln w="12700">
+            <a:solidFill>
+              <a:srgbClr val="C00000"/>
+            </a:solidFill>
+            <a:prstDash val="solid"/>
+            <a:headEnd type="none" w="med" len="med"/>
+            <a:tailEnd type="triangle" w="med" len="med"/>
+          </a:ln>
+        </p:spPr>
+        <p:style>
+          <a:lnRef idx="1">
+            <a:schemeClr val="accent1"/>
+          </a:lnRef>
+          <a:fillRef idx="0">
+            <a:schemeClr val="accent1"/>
+          </a:fillRef>
+          <a:effectRef idx="0">
+            <a:schemeClr val="accent1"/>
+          </a:effectRef>
+          <a:fontRef idx="minor">
+            <a:schemeClr val="tx1"/>
+          </a:fontRef>
+        </p:style>
+      </p:cxnSp>
+      <p:sp>
+        <p:nvSpPr>
+          <p:cNvPr id="182" name="사각형: 둥근 모서리 12">
+            <a:extLst>
+              <a:ext uri="{FF2B5EF4-FFF2-40B4-BE49-F238E27FC236}">
+                <a16:creationId xmlns:a16="http://schemas.microsoft.com/office/drawing/2014/main" id="{EE780FCF-6A0D-D754-192A-EBF70E34BDAD}"/>
+              </a:ext>
+            </a:extLst>
+          </p:cNvPr>
+          <p:cNvSpPr/>
+          <p:nvPr/>
+        </p:nvSpPr>
+        <p:spPr>
+          <a:xfrm>
+            <a:off x="7665327" y="1692013"/>
+            <a:ext cx="1299637" cy="442788"/>
+          </a:xfrm>
+          <a:prstGeom prst="roundRect">
+            <a:avLst>
+              <a:gd name="adj" fmla="val 14105"/>
+            </a:avLst>
+          </a:prstGeom>
+          <a:noFill/>
+          <a:ln w="12700">
+            <a:headEnd type="none" w="med" len="med"/>
+            <a:tailEnd type="triangle" w="med" len="med"/>
+          </a:ln>
+        </p:spPr>
+        <p:style>
+          <a:lnRef idx="2">
+            <a:schemeClr val="dk1"/>
+          </a:lnRef>
+          <a:fillRef idx="1">
+            <a:schemeClr val="lt1"/>
+          </a:fillRef>
+          <a:effectRef idx="0">
+            <a:schemeClr val="dk1"/>
+          </a:effectRef>
+          <a:fontRef idx="minor">
+            <a:schemeClr val="dk1"/>
+          </a:fontRef>
+        </p:style>
+        <p:txBody>
+          <a:bodyPr rtlCol="0" anchor="ctr"/>
+          <a:lstStyle/>
+          <a:p>
+            <a:pPr algn="ctr"/>
+            <a:r>
+              <a:rPr lang="en-US" altLang="ko-KR" sz="900" dirty="0" err="1"/>
+              <a:t>vllm-llama3-8b-epp</a:t>
+            </a:r>
+            <a:br>
+              <a:rPr lang="en-US" altLang="ko-KR" sz="900" dirty="0" err="1"/>
+            </a:br>
+            <a:r>
+              <a:rPr lang="en-US" altLang="ko-KR" sz="900" b="1" dirty="0" err="1"/>
+              <a:t>Pod</a:t>
+            </a:r>
+            <a:endParaRPr lang="en-US" altLang="ko-KR" sz="900" dirty="0"/>
+          </a:p>
+        </p:txBody>
+      </p:sp>
+      <p:cxnSp>
+        <p:nvCxnSpPr>
+          <p:cNvPr id="271" name="직선 화살표 연결선 96">
+            <a:extLst>
+              <a:ext uri="{FF2B5EF4-FFF2-40B4-BE49-F238E27FC236}">
+                <a16:creationId xmlns:a16="http://schemas.microsoft.com/office/drawing/2014/main" id="{FE7F3EDB-9469-97FF-66F2-6542EB705FF3}"/>
+              </a:ext>
+            </a:extLst>
+          </p:cNvPr>
+          <p:cNvCxnSpPr>
+            <a:cxnSpLocks/>
+            <a:stCxn id="117" idx="3"/>
+            <a:endCxn id="182" idx="1"/>
+          </p:cNvCxnSpPr>
+          <p:nvPr/>
+        </p:nvCxnSpPr>
+        <p:spPr>
+          <a:xfrm>
+            <a:off x="7270664" y="1913407"/>
+            <a:ext cx="394663" cy="0"/>
+          </a:xfrm>
+          <a:prstGeom prst="straightConnector1">
+            <a:avLst/>
+          </a:prstGeom>
+          <a:ln w="12700">
+            <a:solidFill>
+              <a:schemeClr val="tx2"/>
+            </a:solidFill>
+            <a:prstDash val="solid"/>
+            <a:headEnd type="none" w="med" len="med"/>
+            <a:tailEnd type="triangle" w="med" len="med"/>
+          </a:ln>
+        </p:spPr>
+        <p:style>
+          <a:lnRef idx="1">
+            <a:schemeClr val="accent1"/>
+          </a:lnRef>
+          <a:fillRef idx="0">
+            <a:schemeClr val="accent1"/>
+          </a:fillRef>
+          <a:effectRef idx="0">
+            <a:schemeClr val="accent1"/>
+          </a:effectRef>
+          <a:fontRef idx="minor">
+            <a:schemeClr val="tx1"/>
+          </a:fontRef>
+        </p:style>
+      </p:cxnSp>
+      <p:sp>
+        <p:nvSpPr>
+          <p:cNvPr id="301" name="사각형: 둥근 모서리 12">
+            <a:extLst>
+              <a:ext uri="{FF2B5EF4-FFF2-40B4-BE49-F238E27FC236}">
+                <a16:creationId xmlns:a16="http://schemas.microsoft.com/office/drawing/2014/main" id="{393E7B1E-D125-2C59-D4CB-4B9B65DAEF9B}"/>
+              </a:ext>
+            </a:extLst>
+          </p:cNvPr>
+          <p:cNvSpPr/>
+          <p:nvPr/>
+        </p:nvSpPr>
+        <p:spPr>
+          <a:xfrm>
+            <a:off x="7665328" y="2571070"/>
+            <a:ext cx="1299636" cy="442788"/>
+          </a:xfrm>
+          <a:prstGeom prst="roundRect">
+            <a:avLst>
+              <a:gd name="adj" fmla="val 14105"/>
+            </a:avLst>
+          </a:prstGeom>
+          <a:noFill/>
+          <a:ln w="12700">
+            <a:headEnd type="none" w="med" len="med"/>
+            <a:tailEnd type="triangle" w="med" len="med"/>
+          </a:ln>
+        </p:spPr>
+        <p:style>
+          <a:lnRef idx="2">
+            <a:schemeClr val="dk1"/>
+          </a:lnRef>
+          <a:fillRef idx="1">
+            <a:schemeClr val="lt1"/>
+          </a:fillRef>
+          <a:effectRef idx="0">
+            <a:schemeClr val="dk1"/>
+          </a:effectRef>
+          <a:fontRef idx="minor">
+            <a:schemeClr val="dk1"/>
+          </a:fontRef>
+        </p:style>
+        <p:txBody>
+          <a:bodyPr rtlCol="0" anchor="ctr"/>
+          <a:lstStyle/>
+          <a:p>
+            <a:pPr algn="ctr"/>
+            <a:r>
+              <a:rPr lang="en-US" altLang="ko-KR" sz="900" dirty="0" err="1"/>
+              <a:t>vllm-llama3-8b</a:t>
+            </a:r>
+          </a:p>
+          <a:p>
+            <a:pPr algn="ctr"/>
+            <a:r>
+              <a:rPr lang="en-US" altLang="ko-KR" sz="900" b="1" dirty="0" err="1"/>
+              <a:t>Pod</a:t>
+            </a:r>
+            <a:endParaRPr lang="en-US" altLang="ko-KR" sz="900" dirty="0"/>
+          </a:p>
+        </p:txBody>
+      </p:sp>
+      <p:cxnSp>
+        <p:nvCxnSpPr>
+          <p:cNvPr id="302" name="직선 화살표 연결선 96">
+            <a:extLst>
+              <a:ext uri="{FF2B5EF4-FFF2-40B4-BE49-F238E27FC236}">
+                <a16:creationId xmlns:a16="http://schemas.microsoft.com/office/drawing/2014/main" id="{EB1ACDA9-0A74-BD93-B282-4722ED22A322}"/>
+              </a:ext>
+            </a:extLst>
+          </p:cNvPr>
+          <p:cNvCxnSpPr>
+            <a:cxnSpLocks/>
+            <a:endCxn id="49" idx="3"/>
+          </p:cNvCxnSpPr>
+          <p:nvPr/>
+        </p:nvCxnSpPr>
+        <p:spPr>
+          <a:xfrm flipH="1">
+            <a:off x="2459962" y="1476170"/>
+            <a:ext cx="756452" cy="355915"/>
+          </a:xfrm>
+          <a:prstGeom prst="straightConnector1">
+            <a:avLst/>
+          </a:prstGeom>
+          <a:ln w="12700">
+            <a:solidFill>
+              <a:schemeClr val="tx1"/>
+            </a:solidFill>
+            <a:prstDash val="solid"/>
+            <a:headEnd type="none" w="med" len="med"/>
+            <a:tailEnd type="triangle" w="med" len="med"/>
+          </a:ln>
+        </p:spPr>
+        <p:style>
+          <a:lnRef idx="1">
+            <a:schemeClr val="accent1"/>
+          </a:lnRef>
+          <a:fillRef idx="0">
+            <a:schemeClr val="accent1"/>
+          </a:fillRef>
+          <a:effectRef idx="0">
+            <a:schemeClr val="accent1"/>
+          </a:effectRef>
+          <a:fontRef idx="minor">
+            <a:schemeClr val="tx1"/>
+          </a:fontRef>
+        </p:style>
+      </p:cxnSp>
+      <p:sp>
+        <p:nvSpPr>
+          <p:cNvPr id="306" name="사각형: 둥근 모서리 12">
+            <a:extLst>
+              <a:ext uri="{FF2B5EF4-FFF2-40B4-BE49-F238E27FC236}">
+                <a16:creationId xmlns:a16="http://schemas.microsoft.com/office/drawing/2014/main" id="{3450226A-AB56-D95D-CFAE-0E9035A8B7E8}"/>
+              </a:ext>
+            </a:extLst>
+          </p:cNvPr>
+          <p:cNvSpPr/>
+          <p:nvPr/>
+        </p:nvSpPr>
+        <p:spPr>
+          <a:xfrm>
+            <a:off x="7665328" y="3137663"/>
+            <a:ext cx="1299636" cy="442788"/>
+          </a:xfrm>
+          <a:prstGeom prst="roundRect">
+            <a:avLst>
+              <a:gd name="adj" fmla="val 14105"/>
+            </a:avLst>
+          </a:prstGeom>
+          <a:noFill/>
+          <a:ln w="12700">
+            <a:headEnd type="none" w="med" len="med"/>
+            <a:tailEnd type="triangle" w="med" len="med"/>
+          </a:ln>
+        </p:spPr>
+        <p:style>
+          <a:lnRef idx="2">
+            <a:schemeClr val="dk1"/>
+          </a:lnRef>
+          <a:fillRef idx="1">
+            <a:schemeClr val="lt1"/>
+          </a:fillRef>
+          <a:effectRef idx="0">
+            <a:schemeClr val="dk1"/>
+          </a:effectRef>
+          <a:fontRef idx="minor">
+            <a:schemeClr val="dk1"/>
+          </a:fontRef>
+        </p:style>
+        <p:txBody>
+          <a:bodyPr rtlCol="0" anchor="ctr"/>
+          <a:lstStyle/>
+          <a:p>
+            <a:pPr algn="ctr"/>
+            <a:r>
+              <a:rPr lang="en-US" altLang="ko-KR" sz="900" dirty="0" err="1"/>
+              <a:t>vllm-llama3-8b</a:t>
+            </a:r>
+          </a:p>
+          <a:p>
+            <a:pPr algn="ctr"/>
+            <a:r>
+              <a:rPr lang="en-US" altLang="ko-KR" sz="900" b="1" dirty="0" err="1"/>
+              <a:t>Pod</a:t>
+            </a:r>
+            <a:endParaRPr lang="en-US" altLang="ko-KR" sz="900" dirty="0"/>
+          </a:p>
+        </p:txBody>
+      </p:sp>
+      <p:sp>
+        <p:nvSpPr>
+          <p:cNvPr id="307" name="사각형: 둥근 모서리 12">
+            <a:extLst>
+              <a:ext uri="{FF2B5EF4-FFF2-40B4-BE49-F238E27FC236}">
+                <a16:creationId xmlns:a16="http://schemas.microsoft.com/office/drawing/2014/main" id="{D2D32D54-E3D7-46B6-F807-E721F7CF8A52}"/>
+              </a:ext>
+            </a:extLst>
+          </p:cNvPr>
+          <p:cNvSpPr/>
+          <p:nvPr/>
+        </p:nvSpPr>
+        <p:spPr>
+          <a:xfrm>
+            <a:off x="7663615" y="3704256"/>
+            <a:ext cx="1299636" cy="442788"/>
+          </a:xfrm>
+          <a:prstGeom prst="roundRect">
+            <a:avLst>
+              <a:gd name="adj" fmla="val 14105"/>
+            </a:avLst>
+          </a:prstGeom>
+          <a:noFill/>
+          <a:ln w="12700">
+            <a:headEnd type="none" w="med" len="med"/>
+            <a:tailEnd type="triangle" w="med" len="med"/>
+          </a:ln>
+        </p:spPr>
+        <p:style>
+          <a:lnRef idx="2">
+            <a:schemeClr val="dk1"/>
+          </a:lnRef>
+          <a:fillRef idx="1">
+            <a:schemeClr val="lt1"/>
+          </a:fillRef>
+          <a:effectRef idx="0">
+            <a:schemeClr val="dk1"/>
+          </a:effectRef>
+          <a:fontRef idx="minor">
+            <a:schemeClr val="dk1"/>
+          </a:fontRef>
+        </p:style>
+        <p:txBody>
+          <a:bodyPr rtlCol="0" anchor="ctr"/>
+          <a:lstStyle/>
+          <a:p>
+            <a:pPr algn="ctr"/>
+            <a:r>
+              <a:rPr lang="en-US" altLang="ko-KR" sz="900" dirty="0" err="1"/>
+              <a:t>vllm-llama3-8b</a:t>
+            </a:r>
+          </a:p>
+          <a:p>
+            <a:pPr algn="ctr"/>
+            <a:r>
+              <a:rPr lang="en-US" altLang="ko-KR" sz="900" b="1" dirty="0" err="1"/>
+              <a:t>Pod</a:t>
+            </a:r>
+            <a:endParaRPr lang="en-US" altLang="ko-KR" sz="900" dirty="0"/>
+          </a:p>
+        </p:txBody>
+      </p:sp>
+      <p:cxnSp>
+        <p:nvCxnSpPr>
+          <p:cNvPr id="308" name="직선 화살표 연결선 96">
+            <a:extLst>
+              <a:ext uri="{FF2B5EF4-FFF2-40B4-BE49-F238E27FC236}">
+                <a16:creationId xmlns:a16="http://schemas.microsoft.com/office/drawing/2014/main" id="{D7795933-2957-3915-7A0A-6E283C5D27FB}"/>
+              </a:ext>
+            </a:extLst>
+          </p:cNvPr>
+          <p:cNvCxnSpPr>
+            <a:cxnSpLocks/>
+            <a:stCxn id="119" idx="3"/>
+            <a:endCxn id="301" idx="1"/>
+          </p:cNvCxnSpPr>
+          <p:nvPr/>
+        </p:nvCxnSpPr>
+        <p:spPr>
+          <a:xfrm>
+            <a:off x="7287145" y="2792464"/>
+            <a:ext cx="378183" cy="0"/>
+          </a:xfrm>
+          <a:prstGeom prst="straightConnector1">
+            <a:avLst/>
+          </a:prstGeom>
+          <a:ln w="12700">
+            <a:solidFill>
+              <a:srgbClr val="C00000"/>
+            </a:solidFill>
+            <a:prstDash val="solid"/>
+            <a:headEnd type="none" w="med" len="med"/>
+            <a:tailEnd type="triangle" w="med" len="med"/>
+          </a:ln>
+        </p:spPr>
+        <p:style>
+          <a:lnRef idx="1">
+            <a:schemeClr val="accent1"/>
+          </a:lnRef>
+          <a:fillRef idx="0">
+            <a:schemeClr val="accent1"/>
+          </a:fillRef>
+          <a:effectRef idx="0">
+            <a:schemeClr val="accent1"/>
+          </a:effectRef>
+          <a:fontRef idx="minor">
+            <a:schemeClr val="tx1"/>
+          </a:fontRef>
+        </p:style>
+      </p:cxnSp>
+      <p:cxnSp>
+        <p:nvCxnSpPr>
+          <p:cNvPr id="311" name="직선 화살표 연결선 96">
+            <a:extLst>
+              <a:ext uri="{FF2B5EF4-FFF2-40B4-BE49-F238E27FC236}">
+                <a16:creationId xmlns:a16="http://schemas.microsoft.com/office/drawing/2014/main" id="{36396E3B-19B2-E24B-4669-61043078F39D}"/>
+              </a:ext>
+            </a:extLst>
+          </p:cNvPr>
+          <p:cNvCxnSpPr>
+            <a:cxnSpLocks/>
+            <a:stCxn id="119" idx="3"/>
+            <a:endCxn id="306" idx="1"/>
+          </p:cNvCxnSpPr>
+          <p:nvPr/>
+        </p:nvCxnSpPr>
+        <p:spPr>
+          <a:xfrm>
+            <a:off x="7287145" y="2792464"/>
+            <a:ext cx="378183" cy="566593"/>
+          </a:xfrm>
+          <a:prstGeom prst="straightConnector1">
+            <a:avLst/>
+          </a:prstGeom>
+          <a:ln w="12700">
+            <a:solidFill>
+              <a:srgbClr val="C00000"/>
+            </a:solidFill>
+            <a:prstDash val="dash"/>
+            <a:headEnd type="none" w="med" len="med"/>
+            <a:tailEnd type="triangle" w="med" len="med"/>
+          </a:ln>
+        </p:spPr>
+        <p:style>
+          <a:lnRef idx="1">
+            <a:schemeClr val="accent1"/>
+          </a:lnRef>
+          <a:fillRef idx="0">
+            <a:schemeClr val="accent1"/>
+          </a:fillRef>
+          <a:effectRef idx="0">
+            <a:schemeClr val="accent1"/>
+          </a:effectRef>
+          <a:fontRef idx="minor">
+            <a:schemeClr val="tx1"/>
+          </a:fontRef>
+        </p:style>
+      </p:cxnSp>
+      <p:cxnSp>
+        <p:nvCxnSpPr>
+          <p:cNvPr id="314" name="직선 화살표 연결선 96">
+            <a:extLst>
+              <a:ext uri="{FF2B5EF4-FFF2-40B4-BE49-F238E27FC236}">
+                <a16:creationId xmlns:a16="http://schemas.microsoft.com/office/drawing/2014/main" id="{F5268853-6F48-027F-6FDE-5AE1E5E34A28}"/>
+              </a:ext>
+            </a:extLst>
+          </p:cNvPr>
+          <p:cNvCxnSpPr>
+            <a:cxnSpLocks/>
+            <a:stCxn id="119" idx="3"/>
+            <a:endCxn id="307" idx="1"/>
+          </p:cNvCxnSpPr>
+          <p:nvPr/>
+        </p:nvCxnSpPr>
+        <p:spPr>
+          <a:xfrm>
+            <a:off x="7287145" y="2792464"/>
+            <a:ext cx="376470" cy="1133186"/>
+          </a:xfrm>
+          <a:prstGeom prst="straightConnector1">
+            <a:avLst/>
+          </a:prstGeom>
+          <a:ln w="12700">
+            <a:solidFill>
+              <a:srgbClr val="C00000"/>
+            </a:solidFill>
+            <a:prstDash val="dash"/>
+            <a:headEnd type="none" w="med" len="med"/>
+            <a:tailEnd type="triangle" w="med" len="med"/>
+          </a:ln>
+        </p:spPr>
+        <p:style>
+          <a:lnRef idx="1">
+            <a:schemeClr val="accent1"/>
+          </a:lnRef>
+          <a:fillRef idx="0">
+            <a:schemeClr val="accent1"/>
+          </a:fillRef>
+          <a:effectRef idx="0">
+            <a:schemeClr val="accent1"/>
+          </a:effectRef>
+          <a:fontRef idx="minor">
+            <a:schemeClr val="tx1"/>
+          </a:fontRef>
+        </p:style>
+      </p:cxnSp>
+      <p:cxnSp>
+        <p:nvCxnSpPr>
+          <p:cNvPr id="317" name="직선 화살표 연결선 96">
+            <a:extLst>
+              <a:ext uri="{FF2B5EF4-FFF2-40B4-BE49-F238E27FC236}">
+                <a16:creationId xmlns:a16="http://schemas.microsoft.com/office/drawing/2014/main" id="{BB5FD08F-1F4D-C18B-C55A-D7E547719B56}"/>
+              </a:ext>
+            </a:extLst>
+          </p:cNvPr>
+          <p:cNvCxnSpPr>
+            <a:cxnSpLocks/>
+          </p:cNvCxnSpPr>
+          <p:nvPr/>
+        </p:nvCxnSpPr>
+        <p:spPr>
+          <a:xfrm>
+            <a:off x="7687141" y="737843"/>
+            <a:ext cx="323569" cy="0"/>
+          </a:xfrm>
+          <a:prstGeom prst="straightConnector1">
+            <a:avLst/>
+          </a:prstGeom>
+          <a:ln w="12700">
+            <a:solidFill>
+              <a:schemeClr val="tx1"/>
+            </a:solidFill>
+            <a:prstDash val="solid"/>
+            <a:headEnd type="none" w="med" len="med"/>
+            <a:tailEnd type="triangle" w="med" len="med"/>
+          </a:ln>
+        </p:spPr>
+        <p:style>
+          <a:lnRef idx="1">
+            <a:schemeClr val="accent1"/>
+          </a:lnRef>
+          <a:fillRef idx="0">
+            <a:schemeClr val="accent1"/>
+          </a:fillRef>
+          <a:effectRef idx="0">
+            <a:schemeClr val="accent1"/>
+          </a:effectRef>
+          <a:fontRef idx="minor">
+            <a:schemeClr val="tx1"/>
+          </a:fontRef>
+        </p:style>
+      </p:cxnSp>
+      <p:sp>
+        <p:nvSpPr>
+          <p:cNvPr id="318" name="TextBox 317">
+            <a:extLst>
+              <a:ext uri="{FF2B5EF4-FFF2-40B4-BE49-F238E27FC236}">
+                <a16:creationId xmlns:a16="http://schemas.microsoft.com/office/drawing/2014/main" id="{C7105A6B-F722-36FF-A7F4-F39E83A2B68C}"/>
+              </a:ext>
+            </a:extLst>
+          </p:cNvPr>
+          <p:cNvSpPr txBox="1"/>
+          <p:nvPr/>
+        </p:nvSpPr>
+        <p:spPr>
+          <a:xfrm>
+            <a:off x="7982884" y="628073"/>
+            <a:ext cx="909596" cy="230832"/>
+          </a:xfrm>
+          <a:prstGeom prst="rect">
+            <a:avLst/>
+          </a:prstGeom>
+          <a:noFill/>
+        </p:spPr>
+        <p:txBody>
+          <a:bodyPr wrap="square" rtlCol="0">
+            <a:spAutoFit/>
+          </a:bodyPr>
+          <a:lstStyle/>
+          <a:p>
+            <a:r>
+              <a:rPr lang="en-US" sz="900"/>
+              <a:t>RDS</a:t>
+            </a:r>
+            <a:r>
+              <a:rPr lang="ko-KR" altLang="en-US" sz="900"/>
+              <a:t> </a:t>
+            </a:r>
+            <a:r>
+              <a:rPr lang="en-US" altLang="ko-KR" sz="900"/>
+              <a:t>Config</a:t>
+            </a:r>
+            <a:endParaRPr lang="en-KR" sz="900"/>
+          </a:p>
+        </p:txBody>
+      </p:sp>
+      <p:cxnSp>
+        <p:nvCxnSpPr>
+          <p:cNvPr id="323" name="직선 화살표 연결선 96">
+            <a:extLst>
+              <a:ext uri="{FF2B5EF4-FFF2-40B4-BE49-F238E27FC236}">
+                <a16:creationId xmlns:a16="http://schemas.microsoft.com/office/drawing/2014/main" id="{FEAC9F5B-4906-B203-16C0-592CEB30D152}"/>
+              </a:ext>
+            </a:extLst>
+          </p:cNvPr>
+          <p:cNvCxnSpPr>
+            <a:cxnSpLocks/>
+          </p:cNvCxnSpPr>
+          <p:nvPr/>
+        </p:nvCxnSpPr>
+        <p:spPr>
+          <a:xfrm>
+            <a:off x="7688239" y="969253"/>
+            <a:ext cx="323569" cy="0"/>
+          </a:xfrm>
+          <a:prstGeom prst="straightConnector1">
+            <a:avLst/>
+          </a:prstGeom>
+          <a:ln w="12700">
+            <a:solidFill>
+              <a:srgbClr val="C00000"/>
+            </a:solidFill>
+            <a:prstDash val="solid"/>
+            <a:headEnd type="none" w="med" len="med"/>
+            <a:tailEnd type="triangle" w="med" len="med"/>
+          </a:ln>
+        </p:spPr>
+        <p:style>
+          <a:lnRef idx="1">
+            <a:schemeClr val="accent1"/>
+          </a:lnRef>
+          <a:fillRef idx="0">
+            <a:schemeClr val="accent1"/>
+          </a:fillRef>
+          <a:effectRef idx="0">
+            <a:schemeClr val="accent1"/>
+          </a:effectRef>
+          <a:fontRef idx="minor">
+            <a:schemeClr val="tx1"/>
+          </a:fontRef>
+        </p:style>
+      </p:cxnSp>
+      <p:sp>
+        <p:nvSpPr>
+          <p:cNvPr id="324" name="TextBox 323">
+            <a:extLst>
+              <a:ext uri="{FF2B5EF4-FFF2-40B4-BE49-F238E27FC236}">
+                <a16:creationId xmlns:a16="http://schemas.microsoft.com/office/drawing/2014/main" id="{85BF5733-5EE7-8F3E-118B-78835C7FD407}"/>
+              </a:ext>
+            </a:extLst>
+          </p:cNvPr>
+          <p:cNvSpPr txBox="1"/>
+          <p:nvPr/>
+        </p:nvSpPr>
+        <p:spPr>
+          <a:xfrm>
+            <a:off x="7983982" y="859483"/>
+            <a:ext cx="702455" cy="230832"/>
+          </a:xfrm>
+          <a:prstGeom prst="rect">
+            <a:avLst/>
+          </a:prstGeom>
+          <a:noFill/>
+        </p:spPr>
+        <p:txBody>
+          <a:bodyPr wrap="square" rtlCol="0">
+            <a:spAutoFit/>
+          </a:bodyPr>
+          <a:lstStyle/>
+          <a:p>
+            <a:r>
+              <a:rPr lang="en-US" sz="900"/>
+              <a:t>Traffic</a:t>
+            </a:r>
+            <a:endParaRPr lang="en-KR" sz="900"/>
+          </a:p>
+        </p:txBody>
+      </p:sp>
+      <p:cxnSp>
+        <p:nvCxnSpPr>
+          <p:cNvPr id="325" name="직선 화살표 연결선 96">
+            <a:extLst>
+              <a:ext uri="{FF2B5EF4-FFF2-40B4-BE49-F238E27FC236}">
+                <a16:creationId xmlns:a16="http://schemas.microsoft.com/office/drawing/2014/main" id="{74FD1DA3-2BE6-6972-78CD-DAADF57F5642}"/>
+              </a:ext>
+            </a:extLst>
+          </p:cNvPr>
+          <p:cNvCxnSpPr>
+            <a:cxnSpLocks/>
+          </p:cNvCxnSpPr>
+          <p:nvPr/>
+        </p:nvCxnSpPr>
+        <p:spPr>
+          <a:xfrm>
+            <a:off x="7687141" y="1208464"/>
+            <a:ext cx="323569" cy="0"/>
+          </a:xfrm>
+          <a:prstGeom prst="straightConnector1">
+            <a:avLst/>
+          </a:prstGeom>
+          <a:ln w="12700">
+            <a:solidFill>
+              <a:schemeClr val="tx2"/>
+            </a:solidFill>
+            <a:prstDash val="solid"/>
+            <a:headEnd type="none" w="med" len="med"/>
+            <a:tailEnd type="triangle" w="med" len="med"/>
+          </a:ln>
+        </p:spPr>
+        <p:style>
+          <a:lnRef idx="1">
+            <a:schemeClr val="accent1"/>
+          </a:lnRef>
+          <a:fillRef idx="0">
+            <a:schemeClr val="accent1"/>
+          </a:fillRef>
+          <a:effectRef idx="0">
+            <a:schemeClr val="accent1"/>
+          </a:effectRef>
+          <a:fontRef idx="minor">
+            <a:schemeClr val="tx1"/>
+          </a:fontRef>
+        </p:style>
+      </p:cxnSp>
+      <p:cxnSp>
+        <p:nvCxnSpPr>
+          <p:cNvPr id="326" name="직선 화살표 연결선 325">
+            <a:extLst>
+              <a:ext uri="{FF2B5EF4-FFF2-40B4-BE49-F238E27FC236}">
+                <a16:creationId xmlns:a16="http://schemas.microsoft.com/office/drawing/2014/main" id="{F0BFAAD3-7E8E-F860-4FB3-BA99B0911481}"/>
+              </a:ext>
+            </a:extLst>
+          </p:cNvPr>
+          <p:cNvCxnSpPr>
+            <a:cxnSpLocks/>
+          </p:cNvCxnSpPr>
+          <p:nvPr/>
+        </p:nvCxnSpPr>
+        <p:spPr>
+          <a:xfrm>
+            <a:off x="7687141" y="1439875"/>
+            <a:ext cx="323569" cy="0"/>
+          </a:xfrm>
+          <a:prstGeom prst="straightConnector1">
+            <a:avLst/>
+          </a:prstGeom>
+          <a:ln w="12700">
+            <a:solidFill>
+              <a:schemeClr val="accent6"/>
+            </a:solidFill>
+            <a:prstDash val="solid"/>
+            <a:headEnd type="none" w="med" len="med"/>
+            <a:tailEnd type="triangle" w="med" len="med"/>
+          </a:ln>
+        </p:spPr>
+        <p:style>
+          <a:lnRef idx="1">
+            <a:schemeClr val="accent1"/>
+          </a:lnRef>
+          <a:fillRef idx="0">
+            <a:schemeClr val="accent1"/>
+          </a:fillRef>
+          <a:effectRef idx="0">
+            <a:schemeClr val="accent1"/>
+          </a:effectRef>
+          <a:fontRef idx="minor">
+            <a:schemeClr val="tx1"/>
+          </a:fontRef>
+        </p:style>
+      </p:cxnSp>
+      <p:sp>
+        <p:nvSpPr>
+          <p:cNvPr id="327" name="TextBox 326">
+            <a:extLst>
+              <a:ext uri="{FF2B5EF4-FFF2-40B4-BE49-F238E27FC236}">
+                <a16:creationId xmlns:a16="http://schemas.microsoft.com/office/drawing/2014/main" id="{A7A486E7-904F-DDDB-623D-61E4174DB0E1}"/>
+              </a:ext>
+            </a:extLst>
+          </p:cNvPr>
+          <p:cNvSpPr txBox="1"/>
+          <p:nvPr/>
+        </p:nvSpPr>
+        <p:spPr>
+          <a:xfrm>
+            <a:off x="7982884" y="1330105"/>
+            <a:ext cx="817986" cy="230832"/>
+          </a:xfrm>
+          <a:prstGeom prst="rect">
+            <a:avLst/>
+          </a:prstGeom>
+          <a:noFill/>
+        </p:spPr>
+        <p:txBody>
+          <a:bodyPr wrap="square" rtlCol="0">
+            <a:spAutoFit/>
+          </a:bodyPr>
+          <a:lstStyle/>
+          <a:p>
+            <a:r>
+              <a:rPr lang="en-US" sz="900"/>
+              <a:t>Get Metrics</a:t>
+            </a:r>
+            <a:endParaRPr lang="en-KR" sz="900"/>
+          </a:p>
+        </p:txBody>
+      </p:sp>
+      <p:sp>
+        <p:nvSpPr>
+          <p:cNvPr id="328" name="TextBox 327">
+            <a:extLst>
+              <a:ext uri="{FF2B5EF4-FFF2-40B4-BE49-F238E27FC236}">
+                <a16:creationId xmlns:a16="http://schemas.microsoft.com/office/drawing/2014/main" id="{11F4DEF2-A673-158A-34D3-79D1623476AE}"/>
+              </a:ext>
+            </a:extLst>
+          </p:cNvPr>
+          <p:cNvSpPr txBox="1"/>
+          <p:nvPr/>
+        </p:nvSpPr>
+        <p:spPr>
+          <a:xfrm>
+            <a:off x="7982883" y="1098694"/>
+            <a:ext cx="1113729" cy="230832"/>
+          </a:xfrm>
+          <a:prstGeom prst="rect">
+            <a:avLst/>
+          </a:prstGeom>
+          <a:noFill/>
+        </p:spPr>
+        <p:txBody>
+          <a:bodyPr wrap="square" rtlCol="0">
+            <a:spAutoFit/>
+          </a:bodyPr>
+          <a:lstStyle/>
+          <a:p>
+            <a:r>
+              <a:rPr lang="en-US" sz="900"/>
+              <a:t>Select Endpoint</a:t>
+            </a:r>
+            <a:endParaRPr lang="en-KR" sz="900"/>
+          </a:p>
+        </p:txBody>
+      </p:sp>
+      <p:sp>
+        <p:nvSpPr>
+          <p:cNvPr id="335" name="사각형: 둥근 모서리 70">
+            <a:extLst>
+              <a:ext uri="{FF2B5EF4-FFF2-40B4-BE49-F238E27FC236}">
+                <a16:creationId xmlns:a16="http://schemas.microsoft.com/office/drawing/2014/main" id="{51FFB145-27F8-2950-08A4-873F3CEEA723}"/>
+              </a:ext>
+            </a:extLst>
+          </p:cNvPr>
+          <p:cNvSpPr/>
+          <p:nvPr/>
+        </p:nvSpPr>
+        <p:spPr>
+          <a:xfrm>
+            <a:off x="7596810" y="2496709"/>
+            <a:ext cx="1440223" cy="1717481"/>
+          </a:xfrm>
+          <a:prstGeom prst="roundRect">
+            <a:avLst>
+              <a:gd name="adj" fmla="val 5061"/>
+            </a:avLst>
+          </a:prstGeom>
+          <a:noFill/>
+          <a:ln w="12700">
+            <a:prstDash val="dash"/>
+            <a:headEnd type="none" w="med" len="med"/>
+            <a:tailEnd type="triangle" w="med" len="med"/>
+          </a:ln>
+        </p:spPr>
+        <p:style>
+          <a:lnRef idx="2">
+            <a:schemeClr val="dk1"/>
+          </a:lnRef>
+          <a:fillRef idx="1">
+            <a:schemeClr val="lt1"/>
+          </a:fillRef>
+          <a:effectRef idx="0">
+            <a:schemeClr val="dk1"/>
+          </a:effectRef>
+          <a:fontRef idx="minor">
+            <a:schemeClr val="dk1"/>
+          </a:fontRef>
+        </p:style>
+        <p:txBody>
+          <a:bodyPr rtlCol="0" anchor="t"/>
+          <a:lstStyle/>
+          <a:p>
+            <a:pPr algn="r"/>
+            <a:endParaRPr lang="ko-KR" altLang="en-US" sz="1000"/>
+          </a:p>
+        </p:txBody>
+      </p:sp>
+      <p:cxnSp>
+        <p:nvCxnSpPr>
+          <p:cNvPr id="336" name="직선 화살표 연결선 335">
+            <a:extLst>
+              <a:ext uri="{FF2B5EF4-FFF2-40B4-BE49-F238E27FC236}">
+                <a16:creationId xmlns:a16="http://schemas.microsoft.com/office/drawing/2014/main" id="{6ADF4922-17B4-288D-E609-448806F561E4}"/>
+              </a:ext>
+            </a:extLst>
+          </p:cNvPr>
+          <p:cNvCxnSpPr>
+            <a:cxnSpLocks/>
+            <a:stCxn id="182" idx="2"/>
+            <a:endCxn id="335" idx="0"/>
+          </p:cNvCxnSpPr>
+          <p:nvPr/>
+        </p:nvCxnSpPr>
+        <p:spPr>
+          <a:xfrm>
+            <a:off x="8315146" y="2134801"/>
+            <a:ext cx="1776" cy="361908"/>
+          </a:xfrm>
+          <a:prstGeom prst="straightConnector1">
+            <a:avLst/>
+          </a:prstGeom>
+          <a:ln w="12700">
+            <a:solidFill>
+              <a:schemeClr val="accent6"/>
+            </a:solidFill>
+            <a:prstDash val="solid"/>
+            <a:headEnd type="none" w="med" len="med"/>
+            <a:tailEnd type="triangle" w="med" len="med"/>
+          </a:ln>
+        </p:spPr>
+        <p:style>
+          <a:lnRef idx="1">
+            <a:schemeClr val="accent1"/>
+          </a:lnRef>
+          <a:fillRef idx="0">
+            <a:schemeClr val="accent1"/>
+          </a:fillRef>
+          <a:effectRef idx="0">
+            <a:schemeClr val="accent1"/>
+          </a:effectRef>
+          <a:fontRef idx="minor">
+            <a:schemeClr val="tx1"/>
+          </a:fontRef>
+        </p:style>
+      </p:cxnSp>
+      <p:sp>
+        <p:nvSpPr>
+          <p:cNvPr id="350" name="타원 349">
+            <a:extLst>
+              <a:ext uri="{FF2B5EF4-FFF2-40B4-BE49-F238E27FC236}">
+                <a16:creationId xmlns:a16="http://schemas.microsoft.com/office/drawing/2014/main" id="{BBC14D1E-9F81-B689-B521-0E3491755F77}"/>
+              </a:ext>
+            </a:extLst>
+          </p:cNvPr>
+          <p:cNvSpPr/>
+          <p:nvPr/>
+        </p:nvSpPr>
+        <p:spPr>
+          <a:xfrm>
+            <a:off x="2555776" y="2429015"/>
+            <a:ext cx="51803" cy="51803"/>
+          </a:xfrm>
+          <a:prstGeom prst="ellipse">
+            <a:avLst/>
+          </a:prstGeom>
+          <a:solidFill>
+            <a:schemeClr val="tx1"/>
+          </a:solidFill>
+          <a:ln>
+            <a:noFill/>
+          </a:ln>
+        </p:spPr>
+        <p:style>
+          <a:lnRef idx="2">
+            <a:schemeClr val="accent1">
+              <a:shade val="15000"/>
+            </a:schemeClr>
+          </a:lnRef>
+          <a:fillRef idx="1">
+            <a:schemeClr val="accent1"/>
+          </a:fillRef>
+          <a:effectRef idx="0">
+            <a:schemeClr val="accent1"/>
+          </a:effectRef>
+          <a:fontRef idx="minor">
+            <a:schemeClr val="lt1"/>
+          </a:fontRef>
+        </p:style>
+        <p:txBody>
+          <a:bodyPr rtlCol="0" anchor="ctr"/>
+          <a:lstStyle/>
+          <a:p>
+            <a:pPr algn="ctr"/>
+            <a:endParaRPr kumimoji="1" lang="ko-KR" altLang="en-US"/>
+          </a:p>
+        </p:txBody>
+      </p:sp>
+      <p:sp>
+        <p:nvSpPr>
+          <p:cNvPr id="351" name="타원 350">
+            <a:extLst>
+              <a:ext uri="{FF2B5EF4-FFF2-40B4-BE49-F238E27FC236}">
+                <a16:creationId xmlns:a16="http://schemas.microsoft.com/office/drawing/2014/main" id="{D383869F-E992-611D-2A97-1D414063E557}"/>
+              </a:ext>
+            </a:extLst>
+          </p:cNvPr>
+          <p:cNvSpPr/>
+          <p:nvPr/>
+        </p:nvSpPr>
+        <p:spPr>
+          <a:xfrm>
+            <a:off x="2696421" y="2429014"/>
+            <a:ext cx="51803" cy="51803"/>
+          </a:xfrm>
+          <a:prstGeom prst="ellipse">
+            <a:avLst/>
+          </a:prstGeom>
+          <a:solidFill>
+            <a:schemeClr val="tx1"/>
+          </a:solidFill>
+          <a:ln>
+            <a:noFill/>
+          </a:ln>
+        </p:spPr>
+        <p:style>
+          <a:lnRef idx="2">
+            <a:schemeClr val="accent1">
+              <a:shade val="15000"/>
+            </a:schemeClr>
+          </a:lnRef>
+          <a:fillRef idx="1">
+            <a:schemeClr val="accent1"/>
+          </a:fillRef>
+          <a:effectRef idx="0">
+            <a:schemeClr val="accent1"/>
+          </a:effectRef>
+          <a:fontRef idx="minor">
+            <a:schemeClr val="lt1"/>
+          </a:fontRef>
+        </p:style>
+        <p:txBody>
+          <a:bodyPr rtlCol="0" anchor="ctr"/>
+          <a:lstStyle/>
+          <a:p>
+            <a:pPr algn="ctr"/>
+            <a:endParaRPr kumimoji="1" lang="ko-KR" altLang="en-US"/>
+          </a:p>
+        </p:txBody>
+      </p:sp>
+      <p:sp>
+        <p:nvSpPr>
+          <p:cNvPr id="352" name="타원 351">
+            <a:extLst>
+              <a:ext uri="{FF2B5EF4-FFF2-40B4-BE49-F238E27FC236}">
+                <a16:creationId xmlns:a16="http://schemas.microsoft.com/office/drawing/2014/main" id="{E79BC94E-654C-8668-0909-703E027743E4}"/>
+              </a:ext>
+            </a:extLst>
+          </p:cNvPr>
+          <p:cNvSpPr/>
+          <p:nvPr/>
+        </p:nvSpPr>
+        <p:spPr>
+          <a:xfrm>
+            <a:off x="2836430" y="2429014"/>
+            <a:ext cx="51803" cy="51803"/>
+          </a:xfrm>
+          <a:prstGeom prst="ellipse">
+            <a:avLst/>
+          </a:prstGeom>
+          <a:solidFill>
+            <a:schemeClr val="tx1"/>
+          </a:solidFill>
+          <a:ln>
+            <a:noFill/>
+          </a:ln>
+        </p:spPr>
+        <p:style>
+          <a:lnRef idx="2">
+            <a:schemeClr val="accent1">
+              <a:shade val="15000"/>
+            </a:schemeClr>
+          </a:lnRef>
+          <a:fillRef idx="1">
+            <a:schemeClr val="accent1"/>
+          </a:fillRef>
+          <a:effectRef idx="0">
+            <a:schemeClr val="accent1"/>
+          </a:effectRef>
+          <a:fontRef idx="minor">
+            <a:schemeClr val="lt1"/>
+          </a:fontRef>
+        </p:style>
+        <p:txBody>
+          <a:bodyPr rtlCol="0" anchor="ctr"/>
+          <a:lstStyle/>
+          <a:p>
+            <a:pPr algn="ctr"/>
+            <a:endParaRPr kumimoji="1" lang="ko-KR" altLang="en-US"/>
+          </a:p>
+        </p:txBody>
+      </p:sp>
+    </p:spTree>
+    <p:extLst>
+      <p:ext uri="{BB962C8B-B14F-4D97-AF65-F5344CB8AC3E}">
+        <p14:creationId xmlns:p14="http://schemas.microsoft.com/office/powerpoint/2010/main" val="1982933618"/>
+      </p:ext>
+    </p:extLst>
+  </p:cSld>
+  <p:clrMapOvr>
+    <a:masterClrMapping/>
+  </p:clrMapOvr>
+</p:sld>
+</file>
+
+<file path=ppt/slides/slide4.xml><?xml version="1.0" encoding="utf-8"?>
 <p:sld xmlns:a="http://schemas.openxmlformats.org/drawingml/2006/main" xmlns:r="http://schemas.openxmlformats.org/officeDocument/2006/relationships" xmlns:p="http://schemas.openxmlformats.org/presentationml/2006/main">
   <p:cSld>
     <p:spTree>
@@ -10569,7 +13665,7 @@
 </p:sld>
 </file>
 
-<file path=ppt/slides/slide4.xml><?xml version="1.0" encoding="utf-8"?>
+<file path=ppt/slides/slide5.xml><?xml version="1.0" encoding="utf-8"?>
 <p:sld xmlns:a="http://schemas.openxmlformats.org/drawingml/2006/main" xmlns:r="http://schemas.openxmlformats.org/officeDocument/2006/relationships" xmlns:p="http://schemas.openxmlformats.org/presentationml/2006/main">
   <p:cSld>
     <p:spTree>
@@ -13748,7 +16844,7 @@
 </p:sld>
 </file>
 
-<file path=ppt/slides/slide5.xml><?xml version="1.0" encoding="utf-8"?>
+<file path=ppt/slides/slide6.xml><?xml version="1.0" encoding="utf-8"?>
 <p:sld xmlns:a="http://schemas.openxmlformats.org/drawingml/2006/main" xmlns:r="http://schemas.openxmlformats.org/officeDocument/2006/relationships" xmlns:p="http://schemas.openxmlformats.org/presentationml/2006/main">
   <p:cSld>
     <p:spTree>
@@ -16927,7 +20023,7 @@
 </p:sld>
 </file>
 
-<file path=ppt/slides/slide6.xml><?xml version="1.0" encoding="utf-8"?>
+<file path=ppt/slides/slide7.xml><?xml version="1.0" encoding="utf-8"?>
 <p:sld xmlns:a="http://schemas.openxmlformats.org/drawingml/2006/main" xmlns:r="http://schemas.openxmlformats.org/officeDocument/2006/relationships" xmlns:p="http://schemas.openxmlformats.org/presentationml/2006/main">
   <p:cSld>
     <p:spTree>
@@ -20024,7 +23120,7 @@
 </p:sld>
 </file>
 
-<file path=ppt/slides/slide7.xml><?xml version="1.0" encoding="utf-8"?>
+<file path=ppt/slides/slide8.xml><?xml version="1.0" encoding="utf-8"?>
 <p:sld xmlns:a="http://schemas.openxmlformats.org/drawingml/2006/main" xmlns:r="http://schemas.openxmlformats.org/officeDocument/2006/relationships" xmlns:p="http://schemas.openxmlformats.org/presentationml/2006/main">
   <p:cSld>
     <p:spTree>
@@ -23293,7 +26389,7 @@
 </p:sld>
 </file>
 
-<file path=ppt/slides/slide8.xml><?xml version="1.0" encoding="utf-8"?>
+<file path=ppt/slides/slide9.xml><?xml version="1.0" encoding="utf-8"?>
 <p:sld xmlns:a="http://schemas.openxmlformats.org/drawingml/2006/main" xmlns:r="http://schemas.openxmlformats.org/officeDocument/2006/relationships" xmlns:p="http://schemas.openxmlformats.org/presentationml/2006/main">
   <p:cSld>
     <p:spTree>

</xml_diff>